<commit_message>
Keep the deck reproducible and fix its overflowing text
The charts embed small workbooks with their own timestamps, so normalisation now
reaches inside them. Slides 2, 3, 5-9 had values and titles wrapping into the
text below them in the LibreOffice render.

Co-Authored-By: Claude Opus 5 <noreply@anthropic.com>
</commit_message>
<xml_diff>
--- a/deliverables/board_briefing.pptx
+++ b/deliverables/board_briefing.pptx
@@ -5597,8 +5597,8 @@
         </p:nvSpPr>
         <p:spPr>
           <a:xfrm>
-            <a:off x="822960" y="2331720"/>
-            <a:ext cx="2019223" cy="822960"/>
+            <a:off x="777240" y="2331720"/>
+            <a:ext cx="2110663" cy="731520"/>
           </a:xfrm>
           <a:prstGeom prst="rect">
             <a:avLst/>
@@ -5606,7 +5606,7 @@
           <a:noFill/>
         </p:spPr>
         <p:txBody>
-          <a:bodyPr wrap="square" anchor="t" lIns="0" rIns="0" tIns="0" bIns="0">
+          <a:bodyPr wrap="square" anchor="b" lIns="0" rIns="0" tIns="0" bIns="0">
             <a:spAutoFit/>
           </a:bodyPr>
           <a:lstStyle/>
@@ -5617,13 +5617,13 @@
               </a:spcAft>
             </a:pPr>
             <a:r>
-              <a:rPr sz="4000" b="1" i="0">
+              <a:rPr sz="3000" b="1" i="0">
                 <a:solidFill>
                   <a:srgbClr val="1F3A5F"/>
                 </a:solidFill>
                 <a:latin typeface="Cambria"/>
               </a:rPr>
-              <a:t>7 Jun 2027</a:t>
+              <a:t>Jun 2027</a:t>
             </a:r>
           </a:p>
         </p:txBody>
@@ -5636,8 +5636,8 @@
         </p:nvSpPr>
         <p:spPr>
           <a:xfrm>
-            <a:off x="822960" y="3154680"/>
-            <a:ext cx="2019223" cy="731520"/>
+            <a:off x="777240" y="3154680"/>
+            <a:ext cx="2110663" cy="731520"/>
           </a:xfrm>
           <a:prstGeom prst="rect">
             <a:avLst/>
@@ -5662,7 +5662,7 @@
                 </a:solidFill>
                 <a:latin typeface="Calibri"/>
               </a:rPr>
-              <a:t>first report for all four employers, then every year (Art. 9(2))</a:t>
+              <a:t>first report, due 7 June 2027, for all four employers; then every year (Art. 9(2))</a:t>
             </a:r>
           </a:p>
         </p:txBody>
@@ -5721,8 +5721,8 @@
         </p:nvSpPr>
         <p:spPr>
           <a:xfrm>
-            <a:off x="3665143" y="2331720"/>
-            <a:ext cx="2019223" cy="822960"/>
+            <a:off x="3619423" y="2331720"/>
+            <a:ext cx="2110663" cy="731520"/>
           </a:xfrm>
           <a:prstGeom prst="rect">
             <a:avLst/>
@@ -5730,7 +5730,7 @@
           <a:noFill/>
         </p:spPr>
         <p:txBody>
-          <a:bodyPr wrap="square" anchor="t" lIns="0" rIns="0" tIns="0" bIns="0">
+          <a:bodyPr wrap="square" anchor="b" lIns="0" rIns="0" tIns="0" bIns="0">
             <a:spAutoFit/>
           </a:bodyPr>
           <a:lstStyle/>
@@ -5741,7 +5741,7 @@
               </a:spcAft>
             </a:pPr>
             <a:r>
-              <a:rPr sz="4000" b="1" i="0">
+              <a:rPr sz="3000" b="1" i="0">
                 <a:solidFill>
                   <a:srgbClr val="EB6834"/>
                 </a:solidFill>
@@ -5760,8 +5760,8 @@
         </p:nvSpPr>
         <p:spPr>
           <a:xfrm>
-            <a:off x="3665143" y="3154680"/>
-            <a:ext cx="2019223" cy="731520"/>
+            <a:off x="3619423" y="3154680"/>
+            <a:ext cx="2110663" cy="731520"/>
           </a:xfrm>
           <a:prstGeom prst="rect">
             <a:avLst/>
@@ -5845,8 +5845,8 @@
         </p:nvSpPr>
         <p:spPr>
           <a:xfrm>
-            <a:off x="6507327" y="2331720"/>
-            <a:ext cx="2019223" cy="822960"/>
+            <a:off x="6461607" y="2331720"/>
+            <a:ext cx="2110663" cy="731520"/>
           </a:xfrm>
           <a:prstGeom prst="rect">
             <a:avLst/>
@@ -5854,7 +5854,7 @@
           <a:noFill/>
         </p:spPr>
         <p:txBody>
-          <a:bodyPr wrap="square" anchor="t" lIns="0" rIns="0" tIns="0" bIns="0">
+          <a:bodyPr wrap="square" anchor="b" lIns="0" rIns="0" tIns="0" bIns="0">
             <a:spAutoFit/>
           </a:bodyPr>
           <a:lstStyle/>
@@ -5865,7 +5865,7 @@
               </a:spcAft>
             </a:pPr>
             <a:r>
-              <a:rPr sz="4000" b="1" i="0">
+              <a:rPr sz="3000" b="1" i="0">
                 <a:solidFill>
                   <a:srgbClr val="EB6834"/>
                 </a:solidFill>
@@ -5884,8 +5884,8 @@
         </p:nvSpPr>
         <p:spPr>
           <a:xfrm>
-            <a:off x="6507327" y="3154680"/>
-            <a:ext cx="2019223" cy="731520"/>
+            <a:off x="6461607" y="3154680"/>
+            <a:ext cx="2110663" cy="731520"/>
           </a:xfrm>
           <a:prstGeom prst="rect">
             <a:avLst/>
@@ -5969,8 +5969,8 @@
         </p:nvSpPr>
         <p:spPr>
           <a:xfrm>
-            <a:off x="9349511" y="2331720"/>
-            <a:ext cx="2019223" cy="822960"/>
+            <a:off x="9303791" y="2331720"/>
+            <a:ext cx="2110663" cy="731520"/>
           </a:xfrm>
           <a:prstGeom prst="rect">
             <a:avLst/>
@@ -5978,7 +5978,7 @@
           <a:noFill/>
         </p:spPr>
         <p:txBody>
-          <a:bodyPr wrap="square" anchor="t" lIns="0" rIns="0" tIns="0" bIns="0">
+          <a:bodyPr wrap="square" anchor="b" lIns="0" rIns="0" tIns="0" bIns="0">
             <a:spAutoFit/>
           </a:bodyPr>
           <a:lstStyle/>
@@ -5989,7 +5989,7 @@
               </a:spcAft>
             </a:pPr>
             <a:r>
-              <a:rPr sz="4000" b="1" i="0">
+              <a:rPr sz="3000" b="1" i="0">
                 <a:solidFill>
                   <a:srgbClr val="1F3A5F"/>
                 </a:solidFill>
@@ -6008,8 +6008,8 @@
         </p:nvSpPr>
         <p:spPr>
           <a:xfrm>
-            <a:off x="9349511" y="3154680"/>
-            <a:ext cx="2019223" cy="731520"/>
+            <a:off x="9303791" y="3154680"/>
+            <a:ext cx="2110663" cy="731520"/>
           </a:xfrm>
           <a:prstGeom prst="rect">
             <a:avLst/>
@@ -7046,7 +7046,7 @@
         <p:spPr>
           <a:xfrm>
             <a:off x="548640" y="4343400"/>
-            <a:ext cx="3657600" cy="365760"/>
+            <a:ext cx="7315200" cy="365760"/>
           </a:xfrm>
           <a:prstGeom prst="rect">
             <a:avLst/>
@@ -7179,7 +7179,7 @@
         <p:spPr>
           <a:xfrm>
             <a:off x="3749040" y="4782312"/>
-            <a:ext cx="2286000" cy="640080"/>
+            <a:ext cx="2377440" cy="640080"/>
           </a:xfrm>
           <a:prstGeom prst="rect">
             <a:avLst/>
@@ -7204,7 +7204,7 @@
                 </a:solidFill>
                 <a:latin typeface="Calibri"/>
               </a:rPr>
-              <a:t>D.Lgs. 96/2026 in force since 7 June 2026; collective agreements anchor the categories</a:t>
+              <a:t>D.Lgs. 96/2026, in force 7 June 2026; collective agreements anchor the categories</a:t>
             </a:r>
           </a:p>
         </p:txBody>
@@ -7312,7 +7312,7 @@
         <p:spPr>
           <a:xfrm>
             <a:off x="9418320" y="4782312"/>
-            <a:ext cx="2286000" cy="640080"/>
+            <a:ext cx="2377440" cy="640080"/>
           </a:xfrm>
           <a:prstGeom prst="rect">
             <a:avLst/>
@@ -7337,7 +7337,7 @@
                 </a:solidFill>
                 <a:latin typeface="Calibri"/>
               </a:rPr>
-              <a:t>Recruitment rules in force; reporting act still in draft</a:t>
+              <a:t>Recruitment rules in force; the reporting act is a draft</a:t>
             </a:r>
           </a:p>
         </p:txBody>
@@ -7445,7 +7445,7 @@
         <p:spPr>
           <a:xfrm>
             <a:off x="3749040" y="5468112"/>
-            <a:ext cx="2286000" cy="640080"/>
+            <a:ext cx="2377440" cy="640080"/>
           </a:xfrm>
           <a:prstGeom prst="rect">
             <a:avLst/>
@@ -7470,7 +7470,7 @@
                 </a:solidFill>
                 <a:latin typeface="Calibri"/>
               </a:rPr>
-              <a:t>No act adopted yet; Entgelttransparenzgesetz still applies</a:t>
+              <a:t>No act yet; the 2017 pay transparency act still applies</a:t>
             </a:r>
           </a:p>
         </p:txBody>
@@ -7578,7 +7578,7 @@
         <p:spPr>
           <a:xfrm>
             <a:off x="9418320" y="5468112"/>
-            <a:ext cx="2286000" cy="640080"/>
+            <a:ext cx="2377440" cy="640080"/>
           </a:xfrm>
           <a:prstGeom prst="rect">
             <a:avLst/>
@@ -7603,7 +7603,7 @@
                 </a:solidFill>
                 <a:latin typeface="Calibri"/>
               </a:rPr>
-              <a:t>Draft Royal Decree under consultation (August 2026)</a:t>
+              <a:t>Draft Royal Decree, consulted in August 2026</a:t>
             </a:r>
           </a:p>
         </p:txBody>
@@ -8175,7 +8175,7 @@
                 </a:solidFill>
                 <a:latin typeface="Cambria"/>
               </a:rPr>
-              <a:t>Women fill the lowest pay band and thin out at the top</a:t>
+              <a:t>Women fill the lowest pay band, not the highest</a:t>
             </a:r>
           </a:p>
         </p:txBody>
@@ -8576,8 +8576,8 @@
         </p:nvSpPr>
         <p:spPr>
           <a:xfrm>
-            <a:off x="822960" y="2148840"/>
-            <a:ext cx="2966618" cy="822960"/>
+            <a:off x="777240" y="2148840"/>
+            <a:ext cx="3058058" cy="731520"/>
           </a:xfrm>
           <a:prstGeom prst="rect">
             <a:avLst/>
@@ -8585,7 +8585,7 @@
           <a:noFill/>
         </p:spPr>
         <p:txBody>
-          <a:bodyPr wrap="square" anchor="t" lIns="0" rIns="0" tIns="0" bIns="0">
+          <a:bodyPr wrap="square" anchor="b" lIns="0" rIns="0" tIns="0" bIns="0">
             <a:spAutoFit/>
           </a:bodyPr>
           <a:lstStyle/>
@@ -8615,8 +8615,8 @@
         </p:nvSpPr>
         <p:spPr>
           <a:xfrm>
-            <a:off x="822960" y="2971800"/>
-            <a:ext cx="2966618" cy="731520"/>
+            <a:off x="777240" y="2971800"/>
+            <a:ext cx="3058058" cy="731520"/>
           </a:xfrm>
           <a:prstGeom prst="rect">
             <a:avLst/>
@@ -8700,8 +8700,8 @@
         </p:nvSpPr>
         <p:spPr>
           <a:xfrm>
-            <a:off x="4612538" y="2148840"/>
-            <a:ext cx="2966618" cy="822960"/>
+            <a:off x="4566818" y="2148840"/>
+            <a:ext cx="3058058" cy="731520"/>
           </a:xfrm>
           <a:prstGeom prst="rect">
             <a:avLst/>
@@ -8709,7 +8709,7 @@
           <a:noFill/>
         </p:spPr>
         <p:txBody>
-          <a:bodyPr wrap="square" anchor="t" lIns="0" rIns="0" tIns="0" bIns="0">
+          <a:bodyPr wrap="square" anchor="b" lIns="0" rIns="0" tIns="0" bIns="0">
             <a:spAutoFit/>
           </a:bodyPr>
           <a:lstStyle/>
@@ -8726,7 +8726,7 @@
                 </a:solidFill>
                 <a:latin typeface="Cambria"/>
               </a:rPr>
-              <a:t>55% vs 64%</a:t>
+              <a:t>8.2 pts</a:t>
             </a:r>
           </a:p>
         </p:txBody>
@@ -8739,8 +8739,8 @@
         </p:nvSpPr>
         <p:spPr>
           <a:xfrm>
-            <a:off x="4612538" y="2971800"/>
-            <a:ext cx="2966618" cy="731520"/>
+            <a:off x="4566818" y="2971800"/>
+            <a:ext cx="3058058" cy="731520"/>
           </a:xfrm>
           <a:prstGeom prst="rect">
             <a:avLst/>
@@ -8765,7 +8765,7 @@
                 </a:solidFill>
                 <a:latin typeface="Calibri"/>
               </a:rPr>
-              <a:t>of women and of men receive any component</a:t>
+              <a:t>fewer women receive any component: 55% against 64% of men</a:t>
             </a:r>
           </a:p>
         </p:txBody>
@@ -8824,8 +8824,8 @@
         </p:nvSpPr>
         <p:spPr>
           <a:xfrm>
-            <a:off x="8402116" y="2148840"/>
-            <a:ext cx="2966618" cy="822960"/>
+            <a:off x="8356396" y="2148840"/>
+            <a:ext cx="3058058" cy="731520"/>
           </a:xfrm>
           <a:prstGeom prst="rect">
             <a:avLst/>
@@ -8833,7 +8833,7 @@
           <a:noFill/>
         </p:spPr>
         <p:txBody>
-          <a:bodyPr wrap="square" anchor="t" lIns="0" rIns="0" tIns="0" bIns="0">
+          <a:bodyPr wrap="square" anchor="b" lIns="0" rIns="0" tIns="0" bIns="0">
             <a:spAutoFit/>
           </a:bodyPr>
           <a:lstStyle/>
@@ -8850,7 +8850,7 @@
                 </a:solidFill>
                 <a:latin typeface="Cambria"/>
               </a:rPr>
-              <a:t>12.6% vs 15.1%</a:t>
+              <a:t>2.6 pts</a:t>
             </a:r>
           </a:p>
         </p:txBody>
@@ -8863,8 +8863,8 @@
         </p:nvSpPr>
         <p:spPr>
           <a:xfrm>
-            <a:off x="8402116" y="2971800"/>
-            <a:ext cx="2966618" cy="731520"/>
+            <a:off x="8356396" y="2971800"/>
+            <a:ext cx="3058058" cy="731520"/>
           </a:xfrm>
           <a:prstGeom prst="rect">
             <a:avLst/>
@@ -8889,7 +8889,7 @@
                 </a:solidFill>
                 <a:latin typeface="Calibri"/>
               </a:rPr>
-              <a:t>commission as a share of base pay in Sales, women vs men</a:t>
+              <a:t>lower commission rate for women in Sales: 12.6% of base pay against 15.1%</a:t>
             </a:r>
           </a:p>
         </p:txBody>
@@ -9243,7 +9243,7 @@
                 </a:solidFill>
                 <a:latin typeface="Cambria"/>
               </a:rPr>
-              <a:t>12 categories need a justification or a remedy by 7 Dec 2027</a:t>
+              <a:t>12 categories to justify or remedy by 7 Dec 2027</a:t>
             </a:r>
           </a:p>
         </p:txBody>
@@ -11580,14 +11580,53 @@
       </p:sp>
       <p:sp>
         <p:nvSpPr>
-          <p:cNvPr id="10" name="Rounded Rectangle 9"/>
+          <p:cNvPr id="10" name="TextBox 9"/>
+          <p:cNvSpPr txBox="1"/>
+          <p:nvPr/>
+        </p:nvSpPr>
+        <p:spPr>
+          <a:xfrm>
+            <a:off x="5669280" y="2011680"/>
+            <a:ext cx="5943600" cy="914400"/>
+          </a:xfrm>
+          <a:prstGeom prst="rect">
+            <a:avLst/>
+          </a:prstGeom>
+          <a:noFill/>
+        </p:spPr>
+        <p:txBody>
+          <a:bodyPr wrap="square" anchor="t" lIns="0" rIns="0" tIns="0" bIns="0">
+            <a:spAutoFit/>
+          </a:bodyPr>
+          <a:lstStyle/>
+          <a:p>
+            <a:pPr algn="l">
+              <a:spcAft>
+                <a:spcPts val="600"/>
+              </a:spcAft>
+            </a:pPr>
+            <a:r>
+              <a:rPr sz="1600" b="0" i="0">
+                <a:solidFill>
+                  <a:srgbClr val="5F6B7A"/>
+                </a:solidFill>
+                <a:latin typeface="Calibri"/>
+              </a:rPr>
+              <a:t>The missing pieces are the ones workers and applicants see first: pay ranges, published criteria, an answer to their questions.</a:t>
+            </a:r>
+          </a:p>
+        </p:txBody>
+      </p:sp>
+      <p:sp>
+        <p:nvSpPr>
+          <p:cNvPr id="11" name="Rounded Rectangle 10"/>
           <p:cNvSpPr/>
           <p:nvPr/>
         </p:nvSpPr>
         <p:spPr>
           <a:xfrm>
-            <a:off x="548640" y="3337560"/>
-            <a:ext cx="3515258" cy="822960"/>
+            <a:off x="548640" y="3246120"/>
+            <a:ext cx="2602153" cy="1371600"/>
           </a:xfrm>
           <a:prstGeom prst="roundRect">
             <a:avLst>
@@ -11626,14 +11665,14 @@
       </p:sp>
       <p:sp>
         <p:nvSpPr>
-          <p:cNvPr id="11" name="TextBox 10"/>
+          <p:cNvPr id="12" name="TextBox 11"/>
           <p:cNvSpPr txBox="1"/>
           <p:nvPr/>
         </p:nvSpPr>
         <p:spPr>
           <a:xfrm>
-            <a:off x="731520" y="3447288"/>
-            <a:ext cx="3149498" cy="640080"/>
+            <a:off x="713232" y="3374136"/>
+            <a:ext cx="2272969" cy="1143000"/>
           </a:xfrm>
           <a:prstGeom prst="rect">
             <a:avLst/>
@@ -11648,7 +11687,7 @@
           <a:p>
             <a:pPr algn="l">
               <a:spcAft>
-                <a:spcPts val="200"/>
+                <a:spcPts val="300"/>
               </a:spcAft>
             </a:pPr>
             <a:r>
@@ -11668,7 +11707,7 @@
               </a:spcAft>
             </a:pPr>
             <a:r>
-              <a:rPr sz="1200" b="0" i="0">
+              <a:rPr sz="1100" b="0" i="0">
                 <a:solidFill>
                   <a:srgbClr val="1B2430"/>
                 </a:solidFill>
@@ -11681,14 +11720,14 @@
       </p:sp>
       <p:sp>
         <p:nvSpPr>
-          <p:cNvPr id="12" name="Rounded Rectangle 11"/>
+          <p:cNvPr id="13" name="Rounded Rectangle 12"/>
           <p:cNvSpPr/>
           <p:nvPr/>
         </p:nvSpPr>
         <p:spPr>
           <a:xfrm>
-            <a:off x="4338218" y="3337560"/>
-            <a:ext cx="3515258" cy="822960"/>
+            <a:off x="3379393" y="3246120"/>
+            <a:ext cx="2602153" cy="1371600"/>
           </a:xfrm>
           <a:prstGeom prst="roundRect">
             <a:avLst>
@@ -11727,14 +11766,14 @@
       </p:sp>
       <p:sp>
         <p:nvSpPr>
-          <p:cNvPr id="13" name="TextBox 12"/>
+          <p:cNvPr id="14" name="TextBox 13"/>
           <p:cNvSpPr txBox="1"/>
           <p:nvPr/>
         </p:nvSpPr>
         <p:spPr>
           <a:xfrm>
-            <a:off x="4521098" y="3447288"/>
-            <a:ext cx="3149498" cy="640080"/>
+            <a:off x="3543985" y="3374136"/>
+            <a:ext cx="2272969" cy="1143000"/>
           </a:xfrm>
           <a:prstGeom prst="rect">
             <a:avLst/>
@@ -11749,7 +11788,7 @@
           <a:p>
             <a:pPr algn="l">
               <a:spcAft>
-                <a:spcPts val="200"/>
+                <a:spcPts val="300"/>
               </a:spcAft>
             </a:pPr>
             <a:r>
@@ -11769,7 +11808,7 @@
               </a:spcAft>
             </a:pPr>
             <a:r>
-              <a:rPr sz="1200" b="0" i="0">
+              <a:rPr sz="1100" b="0" i="0">
                 <a:solidFill>
                   <a:srgbClr val="1B2430"/>
                 </a:solidFill>
@@ -11782,14 +11821,14 @@
       </p:sp>
       <p:sp>
         <p:nvSpPr>
-          <p:cNvPr id="14" name="Rounded Rectangle 13"/>
+          <p:cNvPr id="15" name="Rounded Rectangle 14"/>
           <p:cNvSpPr/>
           <p:nvPr/>
         </p:nvSpPr>
         <p:spPr>
           <a:xfrm>
-            <a:off x="8127796" y="3337560"/>
-            <a:ext cx="3515258" cy="822960"/>
+            <a:off x="6210147" y="3246120"/>
+            <a:ext cx="2602153" cy="1371600"/>
           </a:xfrm>
           <a:prstGeom prst="roundRect">
             <a:avLst>
@@ -11828,14 +11867,14 @@
       </p:sp>
       <p:sp>
         <p:nvSpPr>
-          <p:cNvPr id="15" name="TextBox 14"/>
+          <p:cNvPr id="16" name="TextBox 15"/>
           <p:cNvSpPr txBox="1"/>
           <p:nvPr/>
         </p:nvSpPr>
         <p:spPr>
           <a:xfrm>
-            <a:off x="8310676" y="3447288"/>
-            <a:ext cx="3149498" cy="640080"/>
+            <a:off x="6374739" y="3374136"/>
+            <a:ext cx="2272969" cy="1143000"/>
           </a:xfrm>
           <a:prstGeom prst="rect">
             <a:avLst/>
@@ -11850,7 +11889,7 @@
           <a:p>
             <a:pPr algn="l">
               <a:spcAft>
-                <a:spcPts val="200"/>
+                <a:spcPts val="300"/>
               </a:spcAft>
             </a:pPr>
             <a:r>
@@ -11870,7 +11909,7 @@
               </a:spcAft>
             </a:pPr>
             <a:r>
-              <a:rPr sz="1200" b="0" i="0">
+              <a:rPr sz="1100" b="0" i="0">
                 <a:solidFill>
                   <a:srgbClr val="1B2430"/>
                 </a:solidFill>
@@ -11883,14 +11922,14 @@
       </p:sp>
       <p:sp>
         <p:nvSpPr>
-          <p:cNvPr id="16" name="Rounded Rectangle 15"/>
+          <p:cNvPr id="17" name="Rounded Rectangle 16"/>
           <p:cNvSpPr/>
           <p:nvPr/>
         </p:nvSpPr>
         <p:spPr>
           <a:xfrm>
-            <a:off x="548640" y="4297680"/>
-            <a:ext cx="3515258" cy="822960"/>
+            <a:off x="9040901" y="3246120"/>
+            <a:ext cx="2602153" cy="1371600"/>
           </a:xfrm>
           <a:prstGeom prst="roundRect">
             <a:avLst>
@@ -11929,14 +11968,14 @@
       </p:sp>
       <p:sp>
         <p:nvSpPr>
-          <p:cNvPr id="17" name="TextBox 16"/>
+          <p:cNvPr id="18" name="TextBox 17"/>
           <p:cNvSpPr txBox="1"/>
           <p:nvPr/>
         </p:nvSpPr>
         <p:spPr>
           <a:xfrm>
-            <a:off x="731520" y="4407408"/>
-            <a:ext cx="3149498" cy="640080"/>
+            <a:off x="9205493" y="3374136"/>
+            <a:ext cx="2272969" cy="1143000"/>
           </a:xfrm>
           <a:prstGeom prst="rect">
             <a:avLst/>
@@ -11951,7 +11990,7 @@
           <a:p>
             <a:pPr algn="l">
               <a:spcAft>
-                <a:spcPts val="200"/>
+                <a:spcPts val="300"/>
               </a:spcAft>
             </a:pPr>
             <a:r>
@@ -11971,7 +12010,7 @@
               </a:spcAft>
             </a:pPr>
             <a:r>
-              <a:rPr sz="1200" b="0" i="0">
+              <a:rPr sz="1100" b="0" i="0">
                 <a:solidFill>
                   <a:srgbClr val="1B2430"/>
                 </a:solidFill>
@@ -11984,14 +12023,14 @@
       </p:sp>
       <p:sp>
         <p:nvSpPr>
-          <p:cNvPr id="18" name="Rounded Rectangle 17"/>
+          <p:cNvPr id="19" name="Rounded Rectangle 18"/>
           <p:cNvSpPr/>
           <p:nvPr/>
         </p:nvSpPr>
         <p:spPr>
           <a:xfrm>
-            <a:off x="4338218" y="4297680"/>
-            <a:ext cx="3515258" cy="822960"/>
+            <a:off x="548640" y="4800600"/>
+            <a:ext cx="2602153" cy="1371600"/>
           </a:xfrm>
           <a:prstGeom prst="roundRect">
             <a:avLst>
@@ -12030,14 +12069,14 @@
       </p:sp>
       <p:sp>
         <p:nvSpPr>
-          <p:cNvPr id="19" name="TextBox 18"/>
+          <p:cNvPr id="20" name="TextBox 19"/>
           <p:cNvSpPr txBox="1"/>
           <p:nvPr/>
         </p:nvSpPr>
         <p:spPr>
           <a:xfrm>
-            <a:off x="4521098" y="4407408"/>
-            <a:ext cx="3149498" cy="640080"/>
+            <a:off x="713232" y="4928616"/>
+            <a:ext cx="2272969" cy="1143000"/>
           </a:xfrm>
           <a:prstGeom prst="rect">
             <a:avLst/>
@@ -12052,7 +12091,7 @@
           <a:p>
             <a:pPr algn="l">
               <a:spcAft>
-                <a:spcPts val="200"/>
+                <a:spcPts val="300"/>
               </a:spcAft>
             </a:pPr>
             <a:r>
@@ -12072,7 +12111,7 @@
               </a:spcAft>
             </a:pPr>
             <a:r>
-              <a:rPr sz="1200" b="0" i="0">
+              <a:rPr sz="1100" b="0" i="0">
                 <a:solidFill>
                   <a:srgbClr val="1B2430"/>
                 </a:solidFill>
@@ -12085,14 +12124,14 @@
       </p:sp>
       <p:sp>
         <p:nvSpPr>
-          <p:cNvPr id="20" name="Rounded Rectangle 19"/>
+          <p:cNvPr id="21" name="Rounded Rectangle 20"/>
           <p:cNvSpPr/>
           <p:nvPr/>
         </p:nvSpPr>
         <p:spPr>
           <a:xfrm>
-            <a:off x="8127796" y="4297680"/>
-            <a:ext cx="3515258" cy="822960"/>
+            <a:off x="3379393" y="4800600"/>
+            <a:ext cx="2602153" cy="1371600"/>
           </a:xfrm>
           <a:prstGeom prst="roundRect">
             <a:avLst>
@@ -12131,14 +12170,14 @@
       </p:sp>
       <p:sp>
         <p:nvSpPr>
-          <p:cNvPr id="21" name="TextBox 20"/>
+          <p:cNvPr id="22" name="TextBox 21"/>
           <p:cNvSpPr txBox="1"/>
           <p:nvPr/>
         </p:nvSpPr>
         <p:spPr>
           <a:xfrm>
-            <a:off x="8310676" y="4407408"/>
-            <a:ext cx="3149498" cy="640080"/>
+            <a:off x="3543985" y="4928616"/>
+            <a:ext cx="2272969" cy="1143000"/>
           </a:xfrm>
           <a:prstGeom prst="rect">
             <a:avLst/>
@@ -12153,7 +12192,7 @@
           <a:p>
             <a:pPr algn="l">
               <a:spcAft>
-                <a:spcPts val="200"/>
+                <a:spcPts val="300"/>
               </a:spcAft>
             </a:pPr>
             <a:r>
@@ -12173,7 +12212,7 @@
               </a:spcAft>
             </a:pPr>
             <a:r>
-              <a:rPr sz="1200" b="0" i="0">
+              <a:rPr sz="1100" b="0" i="0">
                 <a:solidFill>
                   <a:srgbClr val="1B2430"/>
                 </a:solidFill>
@@ -12186,14 +12225,14 @@
       </p:sp>
       <p:sp>
         <p:nvSpPr>
-          <p:cNvPr id="22" name="Rounded Rectangle 21"/>
+          <p:cNvPr id="23" name="Rounded Rectangle 22"/>
           <p:cNvSpPr/>
           <p:nvPr/>
         </p:nvSpPr>
         <p:spPr>
           <a:xfrm>
-            <a:off x="548640" y="5257800"/>
-            <a:ext cx="3515258" cy="822960"/>
+            <a:off x="6210147" y="4800600"/>
+            <a:ext cx="2602153" cy="1371600"/>
           </a:xfrm>
           <a:prstGeom prst="roundRect">
             <a:avLst>
@@ -12232,14 +12271,14 @@
       </p:sp>
       <p:sp>
         <p:nvSpPr>
-          <p:cNvPr id="23" name="TextBox 22"/>
+          <p:cNvPr id="24" name="TextBox 23"/>
           <p:cNvSpPr txBox="1"/>
           <p:nvPr/>
         </p:nvSpPr>
         <p:spPr>
           <a:xfrm>
-            <a:off x="731520" y="5367528"/>
-            <a:ext cx="3149498" cy="640080"/>
+            <a:off x="6374739" y="4928616"/>
+            <a:ext cx="2272969" cy="1143000"/>
           </a:xfrm>
           <a:prstGeom prst="rect">
             <a:avLst/>
@@ -12254,7 +12293,7 @@
           <a:p>
             <a:pPr algn="l">
               <a:spcAft>
-                <a:spcPts val="200"/>
+                <a:spcPts val="300"/>
               </a:spcAft>
             </a:pPr>
             <a:r>
@@ -12274,7 +12313,7 @@
               </a:spcAft>
             </a:pPr>
             <a:r>
-              <a:rPr sz="1200" b="0" i="0">
+              <a:rPr sz="1100" b="0" i="0">
                 <a:solidFill>
                   <a:srgbClr val="1B2430"/>
                 </a:solidFill>
@@ -12287,7 +12326,7 @@
       </p:sp>
       <p:sp>
         <p:nvSpPr>
-          <p:cNvPr id="24" name="TextBox 23"/>
+          <p:cNvPr id="25" name="TextBox 24"/>
           <p:cNvSpPr txBox="1"/>
           <p:nvPr/>
         </p:nvSpPr>
@@ -12326,7 +12365,7 @@
       </p:sp>
       <p:sp>
         <p:nvSpPr>
-          <p:cNvPr id="25" name="TextBox 24"/>
+          <p:cNvPr id="26" name="TextBox 25"/>
           <p:cNvSpPr txBox="1"/>
           <p:nvPr/>
         </p:nvSpPr>
@@ -12589,7 +12628,7 @@
         </p:nvSpPr>
         <p:spPr>
           <a:xfrm>
-            <a:off x="822960" y="2788920"/>
+            <a:off x="822960" y="2743200"/>
             <a:ext cx="2966618" cy="365760"/>
           </a:xfrm>
           <a:prstGeom prst="rect">
@@ -12609,13 +12648,13 @@
               </a:spcAft>
             </a:pPr>
             <a:r>
-              <a:rPr sz="1700" b="1" i="0">
+              <a:rPr sz="1600" b="1" i="0">
                 <a:solidFill>
                   <a:srgbClr val="1B2430"/>
                 </a:solidFill>
                 <a:latin typeface="Calibri"/>
               </a:rPr>
-              <a:t>Agree the job evaluation</a:t>
+              <a:t>Agree job evaluation</a:t>
             </a:r>
           </a:p>
         </p:txBody>
@@ -12628,8 +12667,8 @@
         </p:nvSpPr>
         <p:spPr>
           <a:xfrm>
-            <a:off x="822960" y="3154680"/>
-            <a:ext cx="2966618" cy="594360"/>
+            <a:off x="822960" y="3127248"/>
+            <a:ext cx="2966618" cy="640080"/>
           </a:xfrm>
           <a:prstGeom prst="rect">
             <a:avLst/>
@@ -12765,7 +12804,7 @@
         </p:nvSpPr>
         <p:spPr>
           <a:xfrm>
-            <a:off x="4612538" y="2788920"/>
+            <a:off x="4612538" y="2743200"/>
             <a:ext cx="2966618" cy="365760"/>
           </a:xfrm>
           <a:prstGeom prst="rect">
@@ -12785,13 +12824,13 @@
               </a:spcAft>
             </a:pPr>
             <a:r>
-              <a:rPr sz="1700" b="1" i="0">
+              <a:rPr sz="1600" b="1" i="0">
                 <a:solidFill>
                   <a:srgbClr val="1B2430"/>
                 </a:solidFill>
                 <a:latin typeface="Calibri"/>
               </a:rPr>
-              <a:t>Justify or budget each flag</a:t>
+              <a:t>Justify or budget flags</a:t>
             </a:r>
           </a:p>
         </p:txBody>
@@ -12804,8 +12843,8 @@
         </p:nvSpPr>
         <p:spPr>
           <a:xfrm>
-            <a:off x="4612538" y="3154680"/>
-            <a:ext cx="2966618" cy="594360"/>
+            <a:off x="4612538" y="3127248"/>
+            <a:ext cx="2966618" cy="640080"/>
           </a:xfrm>
           <a:prstGeom prst="rect">
             <a:avLst/>
@@ -12830,7 +12869,7 @@
                 </a:solidFill>
                 <a:latin typeface="Calibri"/>
               </a:rPr>
-              <a:t>Most expensive first; a documented, gender-neutral reason or a remedy.</a:t>
+              <a:t>Most expensive first: a documented, gender-neutral reason or a remedy.</a:t>
             </a:r>
           </a:p>
         </p:txBody>
@@ -12941,7 +12980,7 @@
         </p:nvSpPr>
         <p:spPr>
           <a:xfrm>
-            <a:off x="8402116" y="2788920"/>
+            <a:off x="8402116" y="2743200"/>
             <a:ext cx="2966618" cy="365760"/>
           </a:xfrm>
           <a:prstGeom prst="rect">
@@ -12961,7 +13000,7 @@
               </a:spcAft>
             </a:pPr>
             <a:r>
-              <a:rPr sz="1700" b="1" i="0">
+              <a:rPr sz="1600" b="1" i="0">
                 <a:solidFill>
                   <a:srgbClr val="1B2430"/>
                 </a:solidFill>
@@ -12980,8 +13019,8 @@
         </p:nvSpPr>
         <p:spPr>
           <a:xfrm>
-            <a:off x="8402116" y="3154680"/>
-            <a:ext cx="2966618" cy="594360"/>
+            <a:off x="8402116" y="3127248"/>
+            <a:ext cx="2966618" cy="640080"/>
           </a:xfrm>
           <a:prstGeom prst="rect">
             <a:avLst/>
@@ -13117,7 +13156,7 @@
         </p:nvSpPr>
         <p:spPr>
           <a:xfrm>
-            <a:off x="822960" y="4937760"/>
+            <a:off x="822960" y="4892040"/>
             <a:ext cx="2966618" cy="365760"/>
           </a:xfrm>
           <a:prstGeom prst="rect">
@@ -13137,7 +13176,7 @@
               </a:spcAft>
             </a:pPr>
             <a:r>
-              <a:rPr sz="1700" b="1" i="0">
+              <a:rPr sz="1600" b="1" i="0">
                 <a:solidFill>
                   <a:srgbClr val="1B2430"/>
                 </a:solidFill>
@@ -13156,8 +13195,8 @@
         </p:nvSpPr>
         <p:spPr>
           <a:xfrm>
-            <a:off x="822960" y="5303520"/>
-            <a:ext cx="2966618" cy="594360"/>
+            <a:off x="822960" y="5276088"/>
+            <a:ext cx="2966618" cy="640080"/>
           </a:xfrm>
           <a:prstGeom prst="rect">
             <a:avLst/>
@@ -13293,7 +13332,7 @@
         </p:nvSpPr>
         <p:spPr>
           <a:xfrm>
-            <a:off x="4612538" y="4937760"/>
+            <a:off x="4612538" y="4892040"/>
             <a:ext cx="2966618" cy="365760"/>
           </a:xfrm>
           <a:prstGeom prst="rect">
@@ -13313,13 +13352,13 @@
               </a:spcAft>
             </a:pPr>
             <a:r>
-              <a:rPr sz="1700" b="1" i="0">
+              <a:rPr sz="1600" b="1" i="0">
                 <a:solidFill>
                   <a:srgbClr val="1B2430"/>
                 </a:solidFill>
                 <a:latin typeface="Calibri"/>
               </a:rPr>
-              <a:t>Open the information route</a:t>
+              <a:t>Open information route</a:t>
             </a:r>
           </a:p>
         </p:txBody>
@@ -13332,8 +13371,8 @@
         </p:nvSpPr>
         <p:spPr>
           <a:xfrm>
-            <a:off x="4612538" y="5303520"/>
-            <a:ext cx="2966618" cy="594360"/>
+            <a:off x="4612538" y="5276088"/>
+            <a:ext cx="2966618" cy="640080"/>
           </a:xfrm>
           <a:prstGeom prst="rect">
             <a:avLst/>
@@ -13469,7 +13508,7 @@
         </p:nvSpPr>
         <p:spPr>
           <a:xfrm>
-            <a:off x="8402116" y="4937760"/>
+            <a:off x="8402116" y="4892040"/>
             <a:ext cx="2966618" cy="365760"/>
           </a:xfrm>
           <a:prstGeom prst="rect">
@@ -13489,7 +13528,7 @@
               </a:spcAft>
             </a:pPr>
             <a:r>
-              <a:rPr sz="1700" b="1" i="0">
+              <a:rPr sz="1600" b="1" i="0">
                 <a:solidFill>
                   <a:srgbClr val="1B2430"/>
                 </a:solidFill>
@@ -13508,8 +13547,8 @@
         </p:nvSpPr>
         <p:spPr>
           <a:xfrm>
-            <a:off x="8402116" y="5303520"/>
-            <a:ext cx="2966618" cy="594360"/>
+            <a:off x="8402116" y="5276088"/>
+            <a:ext cx="2966618" cy="640080"/>
           </a:xfrm>
           <a:prstGeom prst="rect">
             <a:avLst/>

</xml_diff>

<commit_message>
Quote slide differences from the rounded figures they sit beside
Co-Authored-By: Claude Opus 5 <noreply@anthropic.com>
</commit_message>
<xml_diff>
--- a/deliverables/board_briefing.pptx
+++ b/deliverables/board_briefing.pptx
@@ -5662,7 +5662,7 @@
                 </a:solidFill>
                 <a:latin typeface="Calibri"/>
               </a:rPr>
-              <a:t>first report, due 7 June 2027, for all four employers; then every year (Art. 9(2))</a:t>
+              <a:t>first report due 7 June 2027, then every year (Art. 9(2))</a:t>
             </a:r>
           </a:p>
         </p:txBody>
@@ -8765,7 +8765,7 @@
                 </a:solidFill>
                 <a:latin typeface="Calibri"/>
               </a:rPr>
-              <a:t>fewer women receive any component: 55% against 64% of men</a:t>
+              <a:t>fewer women receive any component: 55.4% against 63.6% of men</a:t>
             </a:r>
           </a:p>
         </p:txBody>
@@ -8850,7 +8850,7 @@
                 </a:solidFill>
                 <a:latin typeface="Cambria"/>
               </a:rPr>
-              <a:t>2.6 pts</a:t>
+              <a:t>2.5 pts</a:t>
             </a:r>
           </a:p>
         </p:txBody>

</xml_diff>

<commit_message>
Italy's livello retributivo and the EU job evaluation guidelines
D.lgs. 96/2026 computes the gaps, quartile bands and the 5% test on fixed and
continuing pay. The Milan employer now gets both measures in every engine:
an Italy sheet in the workbook (511 reconciliation checks), report section 5,
deck slide 8 and an Italy panel in the browser tool (3,821 values checked).
The categories are rerun with the EC/EIGE guidelines' illustrative weights,
and docs/job-evaluation-eige.md compares the two methods. The Italian decree
was read in the Gazzetta Ufficiale: N01-N04 verified, N11-N14 added.

Co-Authored-By: Claude Opus 5.5 <noreply@anthropic.com>
</commit_message>
<xml_diff>
--- a/deliverables/board_briefing.pptx
+++ b/deliverables/board_briefing.pptx
@@ -15,6 +15,7 @@
     <p:sldId id="263" r:id="rId15"/>
     <p:sldId id="264" r:id="rId16"/>
     <p:sldId id="265" r:id="rId17"/>
+    <p:sldId id="266" r:id="rId18"/>
   </p:sldIdLst>
   <p:sldSz cx="12191695" cy="6858000" type="screen4x3"/>
   <p:notesSz cx="6858000" cy="9144000"/>
@@ -1022,6 +1023,76 @@
 </p:notes>
 </file>
 
+<file path=ppt/notesSlides/notesSlide10.xml><?xml version="1.0" encoding="utf-8"?>
+<p:notes xmlns:a="http://schemas.openxmlformats.org/drawingml/2006/main" xmlns:p="http://schemas.openxmlformats.org/presentationml/2006/main" xmlns:r="http://schemas.openxmlformats.org/officeDocument/2006/relationships">
+  <p:cSld>
+    <p:spTree>
+      <p:nvGrpSpPr>
+        <p:cNvPr id="1" name=""/>
+        <p:cNvGrpSpPr/>
+        <p:nvPr/>
+      </p:nvGrpSpPr>
+      <p:grpSpPr>
+        <a:xfrm>
+          <a:off x="0" y="0"/>
+          <a:ext cx="0" cy="0"/>
+          <a:chOff x="0" y="0"/>
+          <a:chExt cx="0" cy="0"/>
+        </a:xfrm>
+      </p:grpSpPr>
+      <p:sp>
+        <p:nvSpPr>
+          <p:cNvPr id="2" name="Slide Image Placeholder 1"/>
+          <p:cNvSpPr>
+            <a:spLocks noGrp="1"/>
+          </p:cNvSpPr>
+          <p:nvPr>
+            <p:ph type="sldImg" idx="2"/>
+          </p:nvPr>
+        </p:nvSpPr>
+        <p:spPr/>
+      </p:sp>
+      <p:sp>
+        <p:nvSpPr>
+          <p:cNvPr id="3" name="Notes Placeholder 2"/>
+          <p:cNvSpPr>
+            <a:spLocks noGrp="1"/>
+          </p:cNvSpPr>
+          <p:nvPr>
+            <p:ph type="body" idx="3" sz="quarter"/>
+          </p:nvPr>
+        </p:nvSpPr>
+        <p:spPr/>
+        <p:txBody>
+          <a:bodyPr/>
+          <a:lstStyle/>
+          <a:p>
+            <a:r>
+              <a:t>Ask for the three decisions explicitly. The budget is a ceiling, not a spend: justified gaps need documentation, not money.</a:t>
+            </a:r>
+          </a:p>
+        </p:txBody>
+      </p:sp>
+      <p:sp>
+        <p:nvSpPr>
+          <p:cNvPr id="4" name="Slide Number Placeholder 3"/>
+          <p:cNvSpPr>
+            <a:spLocks noGrp="1"/>
+          </p:cNvSpPr>
+          <p:nvPr>
+            <p:ph type="sldNum" idx="5" sz="quarter"/>
+          </p:nvPr>
+        </p:nvSpPr>
+        <p:spPr/>
+      </p:sp>
+    </p:spTree>
+  </p:cSld>
+  <p:clrMapOvr>
+    <a:masterClrMapping/>
+  </p:clrMapOvr>
+</p:notes>
+</file>
+
 <file path=ppt/notesSlides/notesSlide2.xml><?xml version="1.0" encoding="utf-8"?>
 <p:notes xmlns:a="http://schemas.openxmlformats.org/drawingml/2006/main" xmlns:p="http://schemas.openxmlformats.org/presentationml/2006/main" xmlns:r="http://schemas.openxmlformats.org/officeDocument/2006/relationships">
   <p:cSld>
@@ -1487,7 +1558,7 @@
           <a:lstStyle/>
           <a:p>
             <a:r>
-              <a:t>Statuses are illustrative for the demonstration organisation.</a:t>
+              <a:t>Italy's decree defines livello retributivo as fixed and continuing pay, without individual components granted on a personal, discretionary or temporary basis (art. 3(1)(b)); items (a), (c), (f) and the 5% test use it (art. 9, art. 10). Read here as base pay plus shift and car allowances, paid by a general rule. Keep the total-pay figures too: the Directive is the floor, and the Commission's conformity check may settle the definition differently.</a:t>
             </a:r>
           </a:p>
         </p:txBody>
@@ -1557,7 +1628,7 @@
           <a:lstStyle/>
           <a:p>
             <a:r>
-              <a:t>Ask for the three decisions explicitly. The budget is a ceiling, not a spend: justified gaps need documentation, not money.</a:t>
+              <a:t>Statuses are illustrative for the demonstration organisation.</a:t>
             </a:r>
           </a:p>
         </p:txBody>
@@ -4768,6 +4839,1260 @@
 </file>
 
 <file path=ppt/slides/slide10.xml><?xml version="1.0" encoding="utf-8"?>
+<p:sld xmlns:a="http://schemas.openxmlformats.org/drawingml/2006/main" xmlns:p="http://schemas.openxmlformats.org/presentationml/2006/main" xmlns:r="http://schemas.openxmlformats.org/officeDocument/2006/relationships">
+  <p:cSld>
+    <p:bg>
+      <p:bgPr>
+        <a:solidFill>
+          <a:srgbClr val="FFFFFF"/>
+        </a:solidFill>
+        <a:effectLst/>
+      </p:bgPr>
+    </p:bg>
+    <p:spTree>
+      <p:nvGrpSpPr>
+        <p:cNvPr id="1" name=""/>
+        <p:cNvGrpSpPr/>
+        <p:nvPr/>
+      </p:nvGrpSpPr>
+      <p:grpSpPr/>
+      <p:sp>
+        <p:nvSpPr>
+          <p:cNvPr id="2" name="Rounded Rectangle 1"/>
+          <p:cNvSpPr/>
+          <p:nvPr/>
+        </p:nvSpPr>
+        <p:spPr>
+          <a:xfrm>
+            <a:off x="548640" y="411480"/>
+            <a:ext cx="1197864" cy="310896"/>
+          </a:xfrm>
+          <a:prstGeom prst="roundRect">
+            <a:avLst>
+              <a:gd name="adj" fmla="val 50000"/>
+            </a:avLst>
+          </a:prstGeom>
+          <a:solidFill>
+            <a:srgbClr val="1F3A5F"/>
+          </a:solidFill>
+          <a:ln>
+            <a:noFill/>
+          </a:ln>
+          <a:effectLst/>
+        </p:spPr>
+        <p:style>
+          <a:lnRef idx="1">
+            <a:schemeClr val="accent1"/>
+          </a:lnRef>
+          <a:fillRef idx="3">
+            <a:schemeClr val="accent1"/>
+          </a:fillRef>
+          <a:effectRef idx="2">
+            <a:schemeClr val="accent1"/>
+          </a:effectRef>
+          <a:fontRef idx="minor">
+            <a:schemeClr val="lt1"/>
+          </a:fontRef>
+        </p:style>
+        <p:txBody>
+          <a:bodyPr rtlCol="0" anchor="ctr" lIns="0" rIns="0" tIns="0" bIns="0"/>
+          <a:lstStyle/>
+          <a:p>
+            <a:pPr algn="ctr"/>
+            <a:r>
+              <a:rPr sz="1100" b="1">
+                <a:solidFill>
+                  <a:srgbClr val="FFFFFF"/>
+                </a:solidFill>
+                <a:latin typeface="Calibri"/>
+              </a:rPr>
+              <a:t>The plan</a:t>
+            </a:r>
+          </a:p>
+        </p:txBody>
+      </p:sp>
+      <p:sp>
+        <p:nvSpPr>
+          <p:cNvPr id="3" name="TextBox 2"/>
+          <p:cNvSpPr txBox="1"/>
+          <p:nvPr/>
+        </p:nvSpPr>
+        <p:spPr>
+          <a:xfrm>
+            <a:off x="548640" y="868680"/>
+            <a:ext cx="11094415" cy="822960"/>
+          </a:xfrm>
+          <a:prstGeom prst="rect">
+            <a:avLst/>
+          </a:prstGeom>
+          <a:noFill/>
+        </p:spPr>
+        <p:txBody>
+          <a:bodyPr wrap="square" anchor="t" lIns="0" rIns="0" tIns="0" bIns="0">
+            <a:spAutoFit/>
+          </a:bodyPr>
+          <a:lstStyle/>
+          <a:p>
+            <a:pPr algn="l">
+              <a:spcAft>
+                <a:spcPts val="600"/>
+              </a:spcAft>
+            </a:pPr>
+            <a:r>
+              <a:rPr sz="3000" b="1" i="0">
+                <a:solidFill>
+                  <a:srgbClr val="1B2430"/>
+                </a:solidFill>
+                <a:latin typeface="Cambria"/>
+              </a:rPr>
+              <a:t>The next 90 days</a:t>
+            </a:r>
+          </a:p>
+        </p:txBody>
+      </p:sp>
+      <p:sp>
+        <p:nvSpPr>
+          <p:cNvPr id="4" name="Rounded Rectangle 3"/>
+          <p:cNvSpPr/>
+          <p:nvPr/>
+        </p:nvSpPr>
+        <p:spPr>
+          <a:xfrm>
+            <a:off x="548640" y="1920240"/>
+            <a:ext cx="3515258" cy="1874519"/>
+          </a:xfrm>
+          <a:prstGeom prst="roundRect">
+            <a:avLst>
+              <a:gd name="adj" fmla="val 8000"/>
+            </a:avLst>
+          </a:prstGeom>
+          <a:solidFill>
+            <a:srgbClr val="F1F4F8"/>
+          </a:solidFill>
+          <a:ln>
+            <a:noFill/>
+          </a:ln>
+          <a:effectLst/>
+        </p:spPr>
+        <p:style>
+          <a:lnRef idx="1">
+            <a:schemeClr val="accent1"/>
+          </a:lnRef>
+          <a:fillRef idx="3">
+            <a:schemeClr val="accent1"/>
+          </a:fillRef>
+          <a:effectRef idx="2">
+            <a:schemeClr val="accent1"/>
+          </a:effectRef>
+          <a:fontRef idx="minor">
+            <a:schemeClr val="lt1"/>
+          </a:fontRef>
+        </p:style>
+        <p:txBody>
+          <a:bodyPr rtlCol="0" anchor="ctr"/>
+          <a:lstStyle/>
+          <a:p>
+            <a:pPr algn="ctr"/>
+          </a:p>
+        </p:txBody>
+      </p:sp>
+      <p:sp>
+        <p:nvSpPr>
+          <p:cNvPr id="5" name="Oval 4"/>
+          <p:cNvSpPr/>
+          <p:nvPr/>
+        </p:nvSpPr>
+        <p:spPr>
+          <a:xfrm>
+            <a:off x="822960" y="2194560"/>
+            <a:ext cx="457200" cy="457200"/>
+          </a:xfrm>
+          <a:prstGeom prst="ellipse">
+            <a:avLst/>
+          </a:prstGeom>
+          <a:solidFill>
+            <a:srgbClr val="1F3A5F"/>
+          </a:solidFill>
+          <a:ln>
+            <a:noFill/>
+          </a:ln>
+        </p:spPr>
+        <p:style>
+          <a:lnRef idx="1">
+            <a:schemeClr val="accent1"/>
+          </a:lnRef>
+          <a:fillRef idx="3">
+            <a:schemeClr val="accent1"/>
+          </a:fillRef>
+          <a:effectRef idx="2">
+            <a:schemeClr val="accent1"/>
+          </a:effectRef>
+          <a:fontRef idx="minor">
+            <a:schemeClr val="lt1"/>
+          </a:fontRef>
+        </p:style>
+        <p:txBody>
+          <a:bodyPr rtlCol="0" anchor="ctr" lIns="0" rIns="0" tIns="0" bIns="0"/>
+          <a:lstStyle/>
+          <a:p>
+            <a:pPr algn="ctr"/>
+            <a:r>
+              <a:rPr sz="1600" b="1">
+                <a:solidFill>
+                  <a:srgbClr val="FFFFFF"/>
+                </a:solidFill>
+                <a:latin typeface="Calibri"/>
+              </a:rPr>
+              <a:t>1</a:t>
+            </a:r>
+          </a:p>
+        </p:txBody>
+      </p:sp>
+      <p:sp>
+        <p:nvSpPr>
+          <p:cNvPr id="6" name="TextBox 5"/>
+          <p:cNvSpPr txBox="1"/>
+          <p:nvPr/>
+        </p:nvSpPr>
+        <p:spPr>
+          <a:xfrm>
+            <a:off x="822960" y="2743200"/>
+            <a:ext cx="2966618" cy="365760"/>
+          </a:xfrm>
+          <a:prstGeom prst="rect">
+            <a:avLst/>
+          </a:prstGeom>
+          <a:noFill/>
+        </p:spPr>
+        <p:txBody>
+          <a:bodyPr wrap="square" anchor="t" lIns="0" rIns="0" tIns="0" bIns="0">
+            <a:spAutoFit/>
+          </a:bodyPr>
+          <a:lstStyle/>
+          <a:p>
+            <a:pPr algn="l">
+              <a:spcAft>
+                <a:spcPts val="600"/>
+              </a:spcAft>
+            </a:pPr>
+            <a:r>
+              <a:rPr sz="1600" b="1" i="0">
+                <a:solidFill>
+                  <a:srgbClr val="1B2430"/>
+                </a:solidFill>
+                <a:latin typeface="Calibri"/>
+              </a:rPr>
+              <a:t>Agree job evaluation</a:t>
+            </a:r>
+          </a:p>
+        </p:txBody>
+      </p:sp>
+      <p:sp>
+        <p:nvSpPr>
+          <p:cNvPr id="7" name="TextBox 6"/>
+          <p:cNvSpPr txBox="1"/>
+          <p:nvPr/>
+        </p:nvSpPr>
+        <p:spPr>
+          <a:xfrm>
+            <a:off x="822960" y="3127248"/>
+            <a:ext cx="2966618" cy="640080"/>
+          </a:xfrm>
+          <a:prstGeom prst="rect">
+            <a:avLst/>
+          </a:prstGeom>
+          <a:noFill/>
+        </p:spPr>
+        <p:txBody>
+          <a:bodyPr wrap="square" anchor="t" lIns="0" rIns="0" tIns="0" bIns="0">
+            <a:spAutoFit/>
+          </a:bodyPr>
+          <a:lstStyle/>
+          <a:p>
+            <a:pPr algn="l">
+              <a:spcAft>
+                <a:spcPts val="600"/>
+              </a:spcAft>
+            </a:pPr>
+            <a:r>
+              <a:rPr sz="1300" b="0" i="0">
+                <a:solidFill>
+                  <a:srgbClr val="5F6B7A"/>
+                </a:solidFill>
+                <a:latin typeface="Calibri"/>
+              </a:rPr>
+              <a:t>With workers' representatives, starting from the Italian collective agreement.</a:t>
+            </a:r>
+          </a:p>
+        </p:txBody>
+      </p:sp>
+      <p:sp>
+        <p:nvSpPr>
+          <p:cNvPr id="8" name="Rounded Rectangle 7"/>
+          <p:cNvSpPr/>
+          <p:nvPr/>
+        </p:nvSpPr>
+        <p:spPr>
+          <a:xfrm>
+            <a:off x="4338218" y="1920240"/>
+            <a:ext cx="3515258" cy="1874519"/>
+          </a:xfrm>
+          <a:prstGeom prst="roundRect">
+            <a:avLst>
+              <a:gd name="adj" fmla="val 8000"/>
+            </a:avLst>
+          </a:prstGeom>
+          <a:solidFill>
+            <a:srgbClr val="F1F4F8"/>
+          </a:solidFill>
+          <a:ln>
+            <a:noFill/>
+          </a:ln>
+          <a:effectLst/>
+        </p:spPr>
+        <p:style>
+          <a:lnRef idx="1">
+            <a:schemeClr val="accent1"/>
+          </a:lnRef>
+          <a:fillRef idx="3">
+            <a:schemeClr val="accent1"/>
+          </a:fillRef>
+          <a:effectRef idx="2">
+            <a:schemeClr val="accent1"/>
+          </a:effectRef>
+          <a:fontRef idx="minor">
+            <a:schemeClr val="lt1"/>
+          </a:fontRef>
+        </p:style>
+        <p:txBody>
+          <a:bodyPr rtlCol="0" anchor="ctr"/>
+          <a:lstStyle/>
+          <a:p>
+            <a:pPr algn="ctr"/>
+          </a:p>
+        </p:txBody>
+      </p:sp>
+      <p:sp>
+        <p:nvSpPr>
+          <p:cNvPr id="9" name="Oval 8"/>
+          <p:cNvSpPr/>
+          <p:nvPr/>
+        </p:nvSpPr>
+        <p:spPr>
+          <a:xfrm>
+            <a:off x="4612538" y="2194560"/>
+            <a:ext cx="457200" cy="457200"/>
+          </a:xfrm>
+          <a:prstGeom prst="ellipse">
+            <a:avLst/>
+          </a:prstGeom>
+          <a:solidFill>
+            <a:srgbClr val="1F3A5F"/>
+          </a:solidFill>
+          <a:ln>
+            <a:noFill/>
+          </a:ln>
+        </p:spPr>
+        <p:style>
+          <a:lnRef idx="1">
+            <a:schemeClr val="accent1"/>
+          </a:lnRef>
+          <a:fillRef idx="3">
+            <a:schemeClr val="accent1"/>
+          </a:fillRef>
+          <a:effectRef idx="2">
+            <a:schemeClr val="accent1"/>
+          </a:effectRef>
+          <a:fontRef idx="minor">
+            <a:schemeClr val="lt1"/>
+          </a:fontRef>
+        </p:style>
+        <p:txBody>
+          <a:bodyPr rtlCol="0" anchor="ctr" lIns="0" rIns="0" tIns="0" bIns="0"/>
+          <a:lstStyle/>
+          <a:p>
+            <a:pPr algn="ctr"/>
+            <a:r>
+              <a:rPr sz="1600" b="1">
+                <a:solidFill>
+                  <a:srgbClr val="FFFFFF"/>
+                </a:solidFill>
+                <a:latin typeface="Calibri"/>
+              </a:rPr>
+              <a:t>2</a:t>
+            </a:r>
+          </a:p>
+        </p:txBody>
+      </p:sp>
+      <p:sp>
+        <p:nvSpPr>
+          <p:cNvPr id="10" name="TextBox 9"/>
+          <p:cNvSpPr txBox="1"/>
+          <p:nvPr/>
+        </p:nvSpPr>
+        <p:spPr>
+          <a:xfrm>
+            <a:off x="4612538" y="2743200"/>
+            <a:ext cx="2966618" cy="365760"/>
+          </a:xfrm>
+          <a:prstGeom prst="rect">
+            <a:avLst/>
+          </a:prstGeom>
+          <a:noFill/>
+        </p:spPr>
+        <p:txBody>
+          <a:bodyPr wrap="square" anchor="t" lIns="0" rIns="0" tIns="0" bIns="0">
+            <a:spAutoFit/>
+          </a:bodyPr>
+          <a:lstStyle/>
+          <a:p>
+            <a:pPr algn="l">
+              <a:spcAft>
+                <a:spcPts val="600"/>
+              </a:spcAft>
+            </a:pPr>
+            <a:r>
+              <a:rPr sz="1600" b="1" i="0">
+                <a:solidFill>
+                  <a:srgbClr val="1B2430"/>
+                </a:solidFill>
+                <a:latin typeface="Calibri"/>
+              </a:rPr>
+              <a:t>Justify or budget flags</a:t>
+            </a:r>
+          </a:p>
+        </p:txBody>
+      </p:sp>
+      <p:sp>
+        <p:nvSpPr>
+          <p:cNvPr id="11" name="TextBox 10"/>
+          <p:cNvSpPr txBox="1"/>
+          <p:nvPr/>
+        </p:nvSpPr>
+        <p:spPr>
+          <a:xfrm>
+            <a:off x="4612538" y="3127248"/>
+            <a:ext cx="2966618" cy="640080"/>
+          </a:xfrm>
+          <a:prstGeom prst="rect">
+            <a:avLst/>
+          </a:prstGeom>
+          <a:noFill/>
+        </p:spPr>
+        <p:txBody>
+          <a:bodyPr wrap="square" anchor="t" lIns="0" rIns="0" tIns="0" bIns="0">
+            <a:spAutoFit/>
+          </a:bodyPr>
+          <a:lstStyle/>
+          <a:p>
+            <a:pPr algn="l">
+              <a:spcAft>
+                <a:spcPts val="600"/>
+              </a:spcAft>
+            </a:pPr>
+            <a:r>
+              <a:rPr sz="1300" b="0" i="0">
+                <a:solidFill>
+                  <a:srgbClr val="5F6B7A"/>
+                </a:solidFill>
+                <a:latin typeface="Calibri"/>
+              </a:rPr>
+              <a:t>Most expensive first: a documented, gender-neutral reason or a remedy.</a:t>
+            </a:r>
+          </a:p>
+        </p:txBody>
+      </p:sp>
+      <p:sp>
+        <p:nvSpPr>
+          <p:cNvPr id="12" name="Rounded Rectangle 11"/>
+          <p:cNvSpPr/>
+          <p:nvPr/>
+        </p:nvSpPr>
+        <p:spPr>
+          <a:xfrm>
+            <a:off x="8127796" y="1920240"/>
+            <a:ext cx="3515258" cy="1874519"/>
+          </a:xfrm>
+          <a:prstGeom prst="roundRect">
+            <a:avLst>
+              <a:gd name="adj" fmla="val 8000"/>
+            </a:avLst>
+          </a:prstGeom>
+          <a:solidFill>
+            <a:srgbClr val="F1F4F8"/>
+          </a:solidFill>
+          <a:ln>
+            <a:noFill/>
+          </a:ln>
+          <a:effectLst/>
+        </p:spPr>
+        <p:style>
+          <a:lnRef idx="1">
+            <a:schemeClr val="accent1"/>
+          </a:lnRef>
+          <a:fillRef idx="3">
+            <a:schemeClr val="accent1"/>
+          </a:fillRef>
+          <a:effectRef idx="2">
+            <a:schemeClr val="accent1"/>
+          </a:effectRef>
+          <a:fontRef idx="minor">
+            <a:schemeClr val="lt1"/>
+          </a:fontRef>
+        </p:style>
+        <p:txBody>
+          <a:bodyPr rtlCol="0" anchor="ctr"/>
+          <a:lstStyle/>
+          <a:p>
+            <a:pPr algn="ctr"/>
+          </a:p>
+        </p:txBody>
+      </p:sp>
+      <p:sp>
+        <p:nvSpPr>
+          <p:cNvPr id="13" name="Oval 12"/>
+          <p:cNvSpPr/>
+          <p:nvPr/>
+        </p:nvSpPr>
+        <p:spPr>
+          <a:xfrm>
+            <a:off x="8402116" y="2194560"/>
+            <a:ext cx="457200" cy="457200"/>
+          </a:xfrm>
+          <a:prstGeom prst="ellipse">
+            <a:avLst/>
+          </a:prstGeom>
+          <a:solidFill>
+            <a:srgbClr val="1F3A5F"/>
+          </a:solidFill>
+          <a:ln>
+            <a:noFill/>
+          </a:ln>
+        </p:spPr>
+        <p:style>
+          <a:lnRef idx="1">
+            <a:schemeClr val="accent1"/>
+          </a:lnRef>
+          <a:fillRef idx="3">
+            <a:schemeClr val="accent1"/>
+          </a:fillRef>
+          <a:effectRef idx="2">
+            <a:schemeClr val="accent1"/>
+          </a:effectRef>
+          <a:fontRef idx="minor">
+            <a:schemeClr val="lt1"/>
+          </a:fontRef>
+        </p:style>
+        <p:txBody>
+          <a:bodyPr rtlCol="0" anchor="ctr" lIns="0" rIns="0" tIns="0" bIns="0"/>
+          <a:lstStyle/>
+          <a:p>
+            <a:pPr algn="ctr"/>
+            <a:r>
+              <a:rPr sz="1600" b="1">
+                <a:solidFill>
+                  <a:srgbClr val="FFFFFF"/>
+                </a:solidFill>
+                <a:latin typeface="Calibri"/>
+              </a:rPr>
+              <a:t>3</a:t>
+            </a:r>
+          </a:p>
+        </p:txBody>
+      </p:sp>
+      <p:sp>
+        <p:nvSpPr>
+          <p:cNvPr id="14" name="TextBox 13"/>
+          <p:cNvSpPr txBox="1"/>
+          <p:nvPr/>
+        </p:nvSpPr>
+        <p:spPr>
+          <a:xfrm>
+            <a:off x="8402116" y="2743200"/>
+            <a:ext cx="2966618" cy="365760"/>
+          </a:xfrm>
+          <a:prstGeom prst="rect">
+            <a:avLst/>
+          </a:prstGeom>
+          <a:noFill/>
+        </p:spPr>
+        <p:txBody>
+          <a:bodyPr wrap="square" anchor="t" lIns="0" rIns="0" tIns="0" bIns="0">
+            <a:spAutoFit/>
+          </a:bodyPr>
+          <a:lstStyle/>
+          <a:p>
+            <a:pPr algn="l">
+              <a:spcAft>
+                <a:spcPts val="600"/>
+              </a:spcAft>
+            </a:pPr>
+            <a:r>
+              <a:rPr sz="1600" b="1" i="0">
+                <a:solidFill>
+                  <a:srgbClr val="1B2430"/>
+                </a:solidFill>
+                <a:latin typeface="Calibri"/>
+              </a:rPr>
+              <a:t>Review Sales territories</a:t>
+            </a:r>
+          </a:p>
+        </p:txBody>
+      </p:sp>
+      <p:sp>
+        <p:nvSpPr>
+          <p:cNvPr id="15" name="TextBox 14"/>
+          <p:cNvSpPr txBox="1"/>
+          <p:nvPr/>
+        </p:nvSpPr>
+        <p:spPr>
+          <a:xfrm>
+            <a:off x="8402116" y="3127248"/>
+            <a:ext cx="2966618" cy="640080"/>
+          </a:xfrm>
+          <a:prstGeom prst="rect">
+            <a:avLst/>
+          </a:prstGeom>
+          <a:noFill/>
+        </p:spPr>
+        <p:txBody>
+          <a:bodyPr wrap="square" anchor="t" lIns="0" rIns="0" tIns="0" bIns="0">
+            <a:spAutoFit/>
+          </a:bodyPr>
+          <a:lstStyle/>
+          <a:p>
+            <a:pPr algn="l">
+              <a:spcAft>
+                <a:spcPts val="600"/>
+              </a:spcAft>
+            </a:pPr>
+            <a:r>
+              <a:rPr sz="1300" b="0" i="0">
+                <a:solidFill>
+                  <a:srgbClr val="5F6B7A"/>
+                </a:solidFill>
+                <a:latin typeface="Calibri"/>
+              </a:rPr>
+              <a:t>And every other rule that decides who can earn a component.</a:t>
+            </a:r>
+          </a:p>
+        </p:txBody>
+      </p:sp>
+      <p:sp>
+        <p:nvSpPr>
+          <p:cNvPr id="16" name="Rounded Rectangle 15"/>
+          <p:cNvSpPr/>
+          <p:nvPr/>
+        </p:nvSpPr>
+        <p:spPr>
+          <a:xfrm>
+            <a:off x="548640" y="4069080"/>
+            <a:ext cx="3515258" cy="1874519"/>
+          </a:xfrm>
+          <a:prstGeom prst="roundRect">
+            <a:avLst>
+              <a:gd name="adj" fmla="val 8000"/>
+            </a:avLst>
+          </a:prstGeom>
+          <a:solidFill>
+            <a:srgbClr val="F1F4F8"/>
+          </a:solidFill>
+          <a:ln>
+            <a:noFill/>
+          </a:ln>
+          <a:effectLst/>
+        </p:spPr>
+        <p:style>
+          <a:lnRef idx="1">
+            <a:schemeClr val="accent1"/>
+          </a:lnRef>
+          <a:fillRef idx="3">
+            <a:schemeClr val="accent1"/>
+          </a:fillRef>
+          <a:effectRef idx="2">
+            <a:schemeClr val="accent1"/>
+          </a:effectRef>
+          <a:fontRef idx="minor">
+            <a:schemeClr val="lt1"/>
+          </a:fontRef>
+        </p:style>
+        <p:txBody>
+          <a:bodyPr rtlCol="0" anchor="ctr"/>
+          <a:lstStyle/>
+          <a:p>
+            <a:pPr algn="ctr"/>
+          </a:p>
+        </p:txBody>
+      </p:sp>
+      <p:sp>
+        <p:nvSpPr>
+          <p:cNvPr id="17" name="Oval 16"/>
+          <p:cNvSpPr/>
+          <p:nvPr/>
+        </p:nvSpPr>
+        <p:spPr>
+          <a:xfrm>
+            <a:off x="822960" y="4343400"/>
+            <a:ext cx="457200" cy="457200"/>
+          </a:xfrm>
+          <a:prstGeom prst="ellipse">
+            <a:avLst/>
+          </a:prstGeom>
+          <a:solidFill>
+            <a:srgbClr val="1F3A5F"/>
+          </a:solidFill>
+          <a:ln>
+            <a:noFill/>
+          </a:ln>
+        </p:spPr>
+        <p:style>
+          <a:lnRef idx="1">
+            <a:schemeClr val="accent1"/>
+          </a:lnRef>
+          <a:fillRef idx="3">
+            <a:schemeClr val="accent1"/>
+          </a:fillRef>
+          <a:effectRef idx="2">
+            <a:schemeClr val="accent1"/>
+          </a:effectRef>
+          <a:fontRef idx="minor">
+            <a:schemeClr val="lt1"/>
+          </a:fontRef>
+        </p:style>
+        <p:txBody>
+          <a:bodyPr rtlCol="0" anchor="ctr" lIns="0" rIns="0" tIns="0" bIns="0"/>
+          <a:lstStyle/>
+          <a:p>
+            <a:pPr algn="ctr"/>
+            <a:r>
+              <a:rPr sz="1600" b="1">
+                <a:solidFill>
+                  <a:srgbClr val="FFFFFF"/>
+                </a:solidFill>
+                <a:latin typeface="Calibri"/>
+              </a:rPr>
+              <a:t>4</a:t>
+            </a:r>
+          </a:p>
+        </p:txBody>
+      </p:sp>
+      <p:sp>
+        <p:nvSpPr>
+          <p:cNvPr id="18" name="TextBox 17"/>
+          <p:cNvSpPr txBox="1"/>
+          <p:nvPr/>
+        </p:nvSpPr>
+        <p:spPr>
+          <a:xfrm>
+            <a:off x="822960" y="4892040"/>
+            <a:ext cx="2966618" cy="365760"/>
+          </a:xfrm>
+          <a:prstGeom prst="rect">
+            <a:avLst/>
+          </a:prstGeom>
+          <a:noFill/>
+        </p:spPr>
+        <p:txBody>
+          <a:bodyPr wrap="square" anchor="t" lIns="0" rIns="0" tIns="0" bIns="0">
+            <a:spAutoFit/>
+          </a:bodyPr>
+          <a:lstStyle/>
+          <a:p>
+            <a:pPr algn="l">
+              <a:spcAft>
+                <a:spcPts val="600"/>
+              </a:spcAft>
+            </a:pPr>
+            <a:r>
+              <a:rPr sz="1600" b="1" i="0">
+                <a:solidFill>
+                  <a:srgbClr val="1B2430"/>
+                </a:solidFill>
+                <a:latin typeface="Calibri"/>
+              </a:rPr>
+              <a:t>Fix recruitment now</a:t>
+            </a:r>
+          </a:p>
+        </p:txBody>
+      </p:sp>
+      <p:sp>
+        <p:nvSpPr>
+          <p:cNvPr id="19" name="TextBox 18"/>
+          <p:cNvSpPr txBox="1"/>
+          <p:nvPr/>
+        </p:nvSpPr>
+        <p:spPr>
+          <a:xfrm>
+            <a:off x="822960" y="5276088"/>
+            <a:ext cx="2966618" cy="640080"/>
+          </a:xfrm>
+          <a:prstGeom prst="rect">
+            <a:avLst/>
+          </a:prstGeom>
+          <a:noFill/>
+        </p:spPr>
+        <p:txBody>
+          <a:bodyPr wrap="square" anchor="t" lIns="0" rIns="0" tIns="0" bIns="0">
+            <a:spAutoFit/>
+          </a:bodyPr>
+          <a:lstStyle/>
+          <a:p>
+            <a:pPr algn="l">
+              <a:spcAft>
+                <a:spcPts val="600"/>
+              </a:spcAft>
+            </a:pPr>
+            <a:r>
+              <a:rPr sz="1300" b="0" i="0">
+                <a:solidFill>
+                  <a:srgbClr val="5F6B7A"/>
+                </a:solidFill>
+                <a:latin typeface="Calibri"/>
+              </a:rPr>
+              <a:t>Pay ranges in vacancies, no pay-history questions, neutral titles.</a:t>
+            </a:r>
+          </a:p>
+        </p:txBody>
+      </p:sp>
+      <p:sp>
+        <p:nvSpPr>
+          <p:cNvPr id="20" name="Rounded Rectangle 19"/>
+          <p:cNvSpPr/>
+          <p:nvPr/>
+        </p:nvSpPr>
+        <p:spPr>
+          <a:xfrm>
+            <a:off x="4338218" y="4069080"/>
+            <a:ext cx="3515258" cy="1874519"/>
+          </a:xfrm>
+          <a:prstGeom prst="roundRect">
+            <a:avLst>
+              <a:gd name="adj" fmla="val 8000"/>
+            </a:avLst>
+          </a:prstGeom>
+          <a:solidFill>
+            <a:srgbClr val="F1F4F8"/>
+          </a:solidFill>
+          <a:ln>
+            <a:noFill/>
+          </a:ln>
+          <a:effectLst/>
+        </p:spPr>
+        <p:style>
+          <a:lnRef idx="1">
+            <a:schemeClr val="accent1"/>
+          </a:lnRef>
+          <a:fillRef idx="3">
+            <a:schemeClr val="accent1"/>
+          </a:fillRef>
+          <a:effectRef idx="2">
+            <a:schemeClr val="accent1"/>
+          </a:effectRef>
+          <a:fontRef idx="minor">
+            <a:schemeClr val="lt1"/>
+          </a:fontRef>
+        </p:style>
+        <p:txBody>
+          <a:bodyPr rtlCol="0" anchor="ctr"/>
+          <a:lstStyle/>
+          <a:p>
+            <a:pPr algn="ctr"/>
+          </a:p>
+        </p:txBody>
+      </p:sp>
+      <p:sp>
+        <p:nvSpPr>
+          <p:cNvPr id="21" name="Oval 20"/>
+          <p:cNvSpPr/>
+          <p:nvPr/>
+        </p:nvSpPr>
+        <p:spPr>
+          <a:xfrm>
+            <a:off x="4612538" y="4343400"/>
+            <a:ext cx="457200" cy="457200"/>
+          </a:xfrm>
+          <a:prstGeom prst="ellipse">
+            <a:avLst/>
+          </a:prstGeom>
+          <a:solidFill>
+            <a:srgbClr val="1F3A5F"/>
+          </a:solidFill>
+          <a:ln>
+            <a:noFill/>
+          </a:ln>
+        </p:spPr>
+        <p:style>
+          <a:lnRef idx="1">
+            <a:schemeClr val="accent1"/>
+          </a:lnRef>
+          <a:fillRef idx="3">
+            <a:schemeClr val="accent1"/>
+          </a:fillRef>
+          <a:effectRef idx="2">
+            <a:schemeClr val="accent1"/>
+          </a:effectRef>
+          <a:fontRef idx="minor">
+            <a:schemeClr val="lt1"/>
+          </a:fontRef>
+        </p:style>
+        <p:txBody>
+          <a:bodyPr rtlCol="0" anchor="ctr" lIns="0" rIns="0" tIns="0" bIns="0"/>
+          <a:lstStyle/>
+          <a:p>
+            <a:pPr algn="ctr"/>
+            <a:r>
+              <a:rPr sz="1600" b="1">
+                <a:solidFill>
+                  <a:srgbClr val="FFFFFF"/>
+                </a:solidFill>
+                <a:latin typeface="Calibri"/>
+              </a:rPr>
+              <a:t>5</a:t>
+            </a:r>
+          </a:p>
+        </p:txBody>
+      </p:sp>
+      <p:sp>
+        <p:nvSpPr>
+          <p:cNvPr id="22" name="TextBox 21"/>
+          <p:cNvSpPr txBox="1"/>
+          <p:nvPr/>
+        </p:nvSpPr>
+        <p:spPr>
+          <a:xfrm>
+            <a:off x="4612538" y="4892040"/>
+            <a:ext cx="2966618" cy="365760"/>
+          </a:xfrm>
+          <a:prstGeom prst="rect">
+            <a:avLst/>
+          </a:prstGeom>
+          <a:noFill/>
+        </p:spPr>
+        <p:txBody>
+          <a:bodyPr wrap="square" anchor="t" lIns="0" rIns="0" tIns="0" bIns="0">
+            <a:spAutoFit/>
+          </a:bodyPr>
+          <a:lstStyle/>
+          <a:p>
+            <a:pPr algn="l">
+              <a:spcAft>
+                <a:spcPts val="600"/>
+              </a:spcAft>
+            </a:pPr>
+            <a:r>
+              <a:rPr sz="1600" b="1" i="0">
+                <a:solidFill>
+                  <a:srgbClr val="1B2430"/>
+                </a:solidFill>
+                <a:latin typeface="Calibri"/>
+              </a:rPr>
+              <a:t>Open information route</a:t>
+            </a:r>
+          </a:p>
+        </p:txBody>
+      </p:sp>
+      <p:sp>
+        <p:nvSpPr>
+          <p:cNvPr id="23" name="TextBox 22"/>
+          <p:cNvSpPr txBox="1"/>
+          <p:nvPr/>
+        </p:nvSpPr>
+        <p:spPr>
+          <a:xfrm>
+            <a:off x="4612538" y="5276088"/>
+            <a:ext cx="2966618" cy="640080"/>
+          </a:xfrm>
+          <a:prstGeom prst="rect">
+            <a:avLst/>
+          </a:prstGeom>
+          <a:noFill/>
+        </p:spPr>
+        <p:txBody>
+          <a:bodyPr wrap="square" anchor="t" lIns="0" rIns="0" tIns="0" bIns="0">
+            <a:spAutoFit/>
+          </a:bodyPr>
+          <a:lstStyle/>
+          <a:p>
+            <a:pPr algn="l">
+              <a:spcAft>
+                <a:spcPts val="600"/>
+              </a:spcAft>
+            </a:pPr>
+            <a:r>
+              <a:rPr sz="1300" b="0" i="0">
+                <a:solidFill>
+                  <a:srgbClr val="5F6B7A"/>
+                </a:solidFill>
+                <a:latin typeface="Calibri"/>
+              </a:rPr>
+              <a:t>Written answers within two months; an annual notice to workers.</a:t>
+            </a:r>
+          </a:p>
+        </p:txBody>
+      </p:sp>
+      <p:sp>
+        <p:nvSpPr>
+          <p:cNvPr id="24" name="Rounded Rectangle 23"/>
+          <p:cNvSpPr/>
+          <p:nvPr/>
+        </p:nvSpPr>
+        <p:spPr>
+          <a:xfrm>
+            <a:off x="8127796" y="4069080"/>
+            <a:ext cx="3515258" cy="1874519"/>
+          </a:xfrm>
+          <a:prstGeom prst="roundRect">
+            <a:avLst>
+              <a:gd name="adj" fmla="val 8000"/>
+            </a:avLst>
+          </a:prstGeom>
+          <a:solidFill>
+            <a:srgbClr val="F1F4F8"/>
+          </a:solidFill>
+          <a:ln>
+            <a:noFill/>
+          </a:ln>
+          <a:effectLst/>
+        </p:spPr>
+        <p:style>
+          <a:lnRef idx="1">
+            <a:schemeClr val="accent1"/>
+          </a:lnRef>
+          <a:fillRef idx="3">
+            <a:schemeClr val="accent1"/>
+          </a:fillRef>
+          <a:effectRef idx="2">
+            <a:schemeClr val="accent1"/>
+          </a:effectRef>
+          <a:fontRef idx="minor">
+            <a:schemeClr val="lt1"/>
+          </a:fontRef>
+        </p:style>
+        <p:txBody>
+          <a:bodyPr rtlCol="0" anchor="ctr"/>
+          <a:lstStyle/>
+          <a:p>
+            <a:pPr algn="ctr"/>
+          </a:p>
+        </p:txBody>
+      </p:sp>
+      <p:sp>
+        <p:nvSpPr>
+          <p:cNvPr id="25" name="Oval 24"/>
+          <p:cNvSpPr/>
+          <p:nvPr/>
+        </p:nvSpPr>
+        <p:spPr>
+          <a:xfrm>
+            <a:off x="8402116" y="4343400"/>
+            <a:ext cx="457200" cy="457200"/>
+          </a:xfrm>
+          <a:prstGeom prst="ellipse">
+            <a:avLst/>
+          </a:prstGeom>
+          <a:solidFill>
+            <a:srgbClr val="1F3A5F"/>
+          </a:solidFill>
+          <a:ln>
+            <a:noFill/>
+          </a:ln>
+        </p:spPr>
+        <p:style>
+          <a:lnRef idx="1">
+            <a:schemeClr val="accent1"/>
+          </a:lnRef>
+          <a:fillRef idx="3">
+            <a:schemeClr val="accent1"/>
+          </a:fillRef>
+          <a:effectRef idx="2">
+            <a:schemeClr val="accent1"/>
+          </a:effectRef>
+          <a:fontRef idx="minor">
+            <a:schemeClr val="lt1"/>
+          </a:fontRef>
+        </p:style>
+        <p:txBody>
+          <a:bodyPr rtlCol="0" anchor="ctr" lIns="0" rIns="0" tIns="0" bIns="0"/>
+          <a:lstStyle/>
+          <a:p>
+            <a:pPr algn="ctr"/>
+            <a:r>
+              <a:rPr sz="1600" b="1">
+                <a:solidFill>
+                  <a:srgbClr val="FFFFFF"/>
+                </a:solidFill>
+                <a:latin typeface="Calibri"/>
+              </a:rPr>
+              <a:t>6</a:t>
+            </a:r>
+          </a:p>
+        </p:txBody>
+      </p:sp>
+      <p:sp>
+        <p:nvSpPr>
+          <p:cNvPr id="26" name="TextBox 25"/>
+          <p:cNvSpPr txBox="1"/>
+          <p:nvPr/>
+        </p:nvSpPr>
+        <p:spPr>
+          <a:xfrm>
+            <a:off x="8402116" y="4892040"/>
+            <a:ext cx="2966618" cy="365760"/>
+          </a:xfrm>
+          <a:prstGeom prst="rect">
+            <a:avLst/>
+          </a:prstGeom>
+          <a:noFill/>
+        </p:spPr>
+        <p:txBody>
+          <a:bodyPr wrap="square" anchor="t" lIns="0" rIns="0" tIns="0" bIns="0">
+            <a:spAutoFit/>
+          </a:bodyPr>
+          <a:lstStyle/>
+          <a:p>
+            <a:pPr algn="l">
+              <a:spcAft>
+                <a:spcPts val="600"/>
+              </a:spcAft>
+            </a:pPr>
+            <a:r>
+              <a:rPr sz="1600" b="1" i="0">
+                <a:solidFill>
+                  <a:srgbClr val="1B2430"/>
+                </a:solidFill>
+                <a:latin typeface="Calibri"/>
+              </a:rPr>
+              <a:t>Rerun on 2026 payroll</a:t>
+            </a:r>
+          </a:p>
+        </p:txBody>
+      </p:sp>
+      <p:sp>
+        <p:nvSpPr>
+          <p:cNvPr id="27" name="TextBox 26"/>
+          <p:cNvSpPr txBox="1"/>
+          <p:nvPr/>
+        </p:nvSpPr>
+        <p:spPr>
+          <a:xfrm>
+            <a:off x="8402116" y="5276088"/>
+            <a:ext cx="2966618" cy="640080"/>
+          </a:xfrm>
+          <a:prstGeom prst="rect">
+            <a:avLst/>
+          </a:prstGeom>
+          <a:noFill/>
+        </p:spPr>
+        <p:txBody>
+          <a:bodyPr wrap="square" anchor="t" lIns="0" rIns="0" tIns="0" bIns="0">
+            <a:spAutoFit/>
+          </a:bodyPr>
+          <a:lstStyle/>
+          <a:p>
+            <a:pPr algn="l">
+              <a:spcAft>
+                <a:spcPts val="600"/>
+              </a:spcAft>
+            </a:pPr>
+            <a:r>
+              <a:rPr sz="1300" b="0" i="0">
+                <a:solidFill>
+                  <a:srgbClr val="5F6B7A"/>
+                </a:solidFill>
+                <a:latin typeface="Calibri"/>
+              </a:rPr>
+              <a:t>Once national rules are final; management sign-off after consultation.</a:t>
+            </a:r>
+          </a:p>
+        </p:txBody>
+      </p:sp>
+      <p:sp>
+        <p:nvSpPr>
+          <p:cNvPr id="28" name="TextBox 27"/>
+          <p:cNvSpPr txBox="1"/>
+          <p:nvPr/>
+        </p:nvSpPr>
+        <p:spPr>
+          <a:xfrm>
+            <a:off x="548640" y="6446520"/>
+            <a:ext cx="8229600" cy="274320"/>
+          </a:xfrm>
+          <a:prstGeom prst="rect">
+            <a:avLst/>
+          </a:prstGeom>
+          <a:noFill/>
+        </p:spPr>
+        <p:txBody>
+          <a:bodyPr wrap="square" anchor="t" lIns="0" rIns="0" tIns="0" bIns="0">
+            <a:spAutoFit/>
+          </a:bodyPr>
+          <a:lstStyle/>
+          <a:p>
+            <a:pPr algn="l">
+              <a:spcAft>
+                <a:spcPts val="600"/>
+              </a:spcAft>
+            </a:pPr>
+            <a:r>
+              <a:rPr sz="1000" b="0" i="0">
+                <a:solidFill>
+                  <a:srgbClr val="5F6B7A"/>
+                </a:solidFill>
+                <a:latin typeface="Calibri"/>
+              </a:rPr>
+              <a:t>Pay transparency readiness · dry run on synthetic data · not legal advice</a:t>
+            </a:r>
+          </a:p>
+        </p:txBody>
+      </p:sp>
+      <p:sp>
+        <p:nvSpPr>
+          <p:cNvPr id="29" name="TextBox 28"/>
+          <p:cNvSpPr txBox="1"/>
+          <p:nvPr/>
+        </p:nvSpPr>
+        <p:spPr>
+          <a:xfrm>
+            <a:off x="10728655" y="6446520"/>
+            <a:ext cx="914400" cy="274320"/>
+          </a:xfrm>
+          <a:prstGeom prst="rect">
+            <a:avLst/>
+          </a:prstGeom>
+          <a:noFill/>
+        </p:spPr>
+        <p:txBody>
+          <a:bodyPr wrap="square" anchor="t" lIns="0" rIns="0" tIns="0" bIns="0">
+            <a:spAutoFit/>
+          </a:bodyPr>
+          <a:lstStyle/>
+          <a:p>
+            <a:pPr algn="r">
+              <a:spcAft>
+                <a:spcPts val="600"/>
+              </a:spcAft>
+            </a:pPr>
+            <a:r>
+              <a:rPr sz="1000" b="0" i="0">
+                <a:solidFill>
+                  <a:srgbClr val="5F6B7A"/>
+                </a:solidFill>
+                <a:latin typeface="Calibri"/>
+              </a:rPr>
+              <a:t>10</a:t>
+            </a:r>
+          </a:p>
+        </p:txBody>
+      </p:sp>
+    </p:spTree>
+  </p:cSld>
+  <p:clrMapOvr>
+    <a:masterClrMapping/>
+  </p:clrMapOvr>
+</p:sld>
+</file>
+
+<file path=ppt/slides/slide11.xml><?xml version="1.0" encoding="utf-8"?>
 <p:sld xmlns:a="http://schemas.openxmlformats.org/drawingml/2006/main" xmlns:p="http://schemas.openxmlformats.org/presentationml/2006/main" xmlns:r="http://schemas.openxmlformats.org/officeDocument/2006/relationships">
   <p:cSld>
     <p:bg>
@@ -11211,7 +12536,7 @@
         <p:spPr>
           <a:xfrm>
             <a:off x="548640" y="411480"/>
-            <a:ext cx="2075688" cy="310896"/>
+            <a:ext cx="1856231" cy="310896"/>
           </a:xfrm>
           <a:prstGeom prst="roundRect">
             <a:avLst>
@@ -11252,7 +12577,7 @@
                 </a:solidFill>
                 <a:latin typeface="Calibri"/>
               </a:rPr>
-              <a:t>Articles 4 to 12</a:t>
+              <a:t>D.lgs. 96/2026</a:t>
             </a:r>
           </a:p>
         </p:txBody>
@@ -11291,342 +12616,21 @@
                 </a:solidFill>
                 <a:latin typeface="Cambria"/>
               </a:rPr>
-              <a:t>Most of what workers will see is not built yet</a:t>
-            </a:r>
-          </a:p>
-        </p:txBody>
-      </p:sp>
-      <p:sp>
-        <p:nvSpPr>
-          <p:cNvPr id="4" name="TextBox 3"/>
-          <p:cNvSpPr txBox="1"/>
-          <p:nvPr/>
-        </p:nvSpPr>
-        <p:spPr>
-          <a:xfrm>
-            <a:off x="548640" y="1874519"/>
-            <a:ext cx="1371600" cy="731520"/>
-          </a:xfrm>
-          <a:prstGeom prst="rect">
-            <a:avLst/>
-          </a:prstGeom>
-          <a:noFill/>
-        </p:spPr>
-        <p:txBody>
-          <a:bodyPr wrap="square" anchor="t" lIns="0" rIns="0" tIns="0" bIns="0">
-            <a:spAutoFit/>
-          </a:bodyPr>
-          <a:lstStyle/>
-          <a:p>
-            <a:pPr algn="l">
-              <a:spcAft>
-                <a:spcPts val="600"/>
-              </a:spcAft>
-            </a:pPr>
-            <a:r>
-              <a:rPr sz="4000" b="1" i="0">
-                <a:solidFill>
-                  <a:srgbClr val="1B2430"/>
-                </a:solidFill>
-                <a:latin typeface="Cambria"/>
-              </a:rPr>
-              <a:t>1</a:t>
-            </a:r>
-          </a:p>
-        </p:txBody>
-      </p:sp>
-      <p:sp>
-        <p:nvSpPr>
-          <p:cNvPr id="5" name="Rounded Rectangle 4"/>
+              <a:t>In Italy the gap is measured on fixed pay, and Milan's figures change</a:t>
+            </a:r>
+          </a:p>
+        </p:txBody>
+      </p:sp>
+      <p:sp>
+        <p:nvSpPr>
+          <p:cNvPr id="4" name="Rounded Rectangle 3"/>
           <p:cNvSpPr/>
           <p:nvPr/>
         </p:nvSpPr>
         <p:spPr>
           <a:xfrm>
-            <a:off x="548640" y="2651760"/>
-            <a:ext cx="1188720" cy="310896"/>
-          </a:xfrm>
-          <a:prstGeom prst="roundRect">
-            <a:avLst>
-              <a:gd name="adj" fmla="val 50000"/>
-            </a:avLst>
-          </a:prstGeom>
-          <a:solidFill>
-            <a:srgbClr val="0CA30C"/>
-          </a:solidFill>
-          <a:ln>
-            <a:noFill/>
-          </a:ln>
-          <a:effectLst/>
-        </p:spPr>
-        <p:style>
-          <a:lnRef idx="1">
-            <a:schemeClr val="accent1"/>
-          </a:lnRef>
-          <a:fillRef idx="3">
-            <a:schemeClr val="accent1"/>
-          </a:fillRef>
-          <a:effectRef idx="2">
-            <a:schemeClr val="accent1"/>
-          </a:effectRef>
-          <a:fontRef idx="minor">
-            <a:schemeClr val="lt1"/>
-          </a:fontRef>
-        </p:style>
-        <p:txBody>
-          <a:bodyPr rtlCol="0" anchor="ctr" lIns="0" rIns="0" tIns="0" bIns="0"/>
-          <a:lstStyle/>
-          <a:p>
-            <a:pPr algn="ctr"/>
-            <a:r>
-              <a:rPr sz="1100" b="1">
-                <a:solidFill>
-                  <a:srgbClr val="FFFFFF"/>
-                </a:solidFill>
-                <a:latin typeface="Calibri"/>
-              </a:rPr>
-              <a:t>Ready</a:t>
-            </a:r>
-          </a:p>
-        </p:txBody>
-      </p:sp>
-      <p:sp>
-        <p:nvSpPr>
-          <p:cNvPr id="6" name="TextBox 5"/>
-          <p:cNvSpPr txBox="1"/>
-          <p:nvPr/>
-        </p:nvSpPr>
-        <p:spPr>
-          <a:xfrm>
-            <a:off x="2148840" y="1874519"/>
-            <a:ext cx="1371600" cy="731520"/>
-          </a:xfrm>
-          <a:prstGeom prst="rect">
-            <a:avLst/>
-          </a:prstGeom>
-          <a:noFill/>
-        </p:spPr>
-        <p:txBody>
-          <a:bodyPr wrap="square" anchor="t" lIns="0" rIns="0" tIns="0" bIns="0">
-            <a:spAutoFit/>
-          </a:bodyPr>
-          <a:lstStyle/>
-          <a:p>
-            <a:pPr algn="l">
-              <a:spcAft>
-                <a:spcPts val="600"/>
-              </a:spcAft>
-            </a:pPr>
-            <a:r>
-              <a:rPr sz="4000" b="1" i="0">
-                <a:solidFill>
-                  <a:srgbClr val="1B2430"/>
-                </a:solidFill>
-                <a:latin typeface="Cambria"/>
-              </a:rPr>
-              <a:t>6</a:t>
-            </a:r>
-          </a:p>
-        </p:txBody>
-      </p:sp>
-      <p:sp>
-        <p:nvSpPr>
-          <p:cNvPr id="7" name="Rounded Rectangle 6"/>
-          <p:cNvSpPr/>
-          <p:nvPr/>
-        </p:nvSpPr>
-        <p:spPr>
-          <a:xfrm>
-            <a:off x="2148840" y="2651760"/>
-            <a:ext cx="1188720" cy="310896"/>
-          </a:xfrm>
-          <a:prstGeom prst="roundRect">
-            <a:avLst>
-              <a:gd name="adj" fmla="val 50000"/>
-            </a:avLst>
-          </a:prstGeom>
-          <a:solidFill>
-            <a:srgbClr val="FAB219"/>
-          </a:solidFill>
-          <a:ln>
-            <a:noFill/>
-          </a:ln>
-          <a:effectLst/>
-        </p:spPr>
-        <p:style>
-          <a:lnRef idx="1">
-            <a:schemeClr val="accent1"/>
-          </a:lnRef>
-          <a:fillRef idx="3">
-            <a:schemeClr val="accent1"/>
-          </a:fillRef>
-          <a:effectRef idx="2">
-            <a:schemeClr val="accent1"/>
-          </a:effectRef>
-          <a:fontRef idx="minor">
-            <a:schemeClr val="lt1"/>
-          </a:fontRef>
-        </p:style>
-        <p:txBody>
-          <a:bodyPr rtlCol="0" anchor="ctr" lIns="0" rIns="0" tIns="0" bIns="0"/>
-          <a:lstStyle/>
-          <a:p>
-            <a:pPr algn="ctr"/>
-            <a:r>
-              <a:rPr sz="1100" b="1">
-                <a:solidFill>
-                  <a:srgbClr val="1B2430"/>
-                </a:solidFill>
-                <a:latin typeface="Calibri"/>
-              </a:rPr>
-              <a:t>Partial</a:t>
-            </a:r>
-          </a:p>
-        </p:txBody>
-      </p:sp>
-      <p:sp>
-        <p:nvSpPr>
-          <p:cNvPr id="8" name="TextBox 7"/>
-          <p:cNvSpPr txBox="1"/>
-          <p:nvPr/>
-        </p:nvSpPr>
-        <p:spPr>
-          <a:xfrm>
-            <a:off x="3749040" y="1874519"/>
-            <a:ext cx="1371600" cy="731520"/>
-          </a:xfrm>
-          <a:prstGeom prst="rect">
-            <a:avLst/>
-          </a:prstGeom>
-          <a:noFill/>
-        </p:spPr>
-        <p:txBody>
-          <a:bodyPr wrap="square" anchor="t" lIns="0" rIns="0" tIns="0" bIns="0">
-            <a:spAutoFit/>
-          </a:bodyPr>
-          <a:lstStyle/>
-          <a:p>
-            <a:pPr algn="l">
-              <a:spcAft>
-                <a:spcPts val="600"/>
-              </a:spcAft>
-            </a:pPr>
-            <a:r>
-              <a:rPr sz="4000" b="1" i="0">
-                <a:solidFill>
-                  <a:srgbClr val="1B2430"/>
-                </a:solidFill>
-                <a:latin typeface="Cambria"/>
-              </a:rPr>
-              <a:t>7</a:t>
-            </a:r>
-          </a:p>
-        </p:txBody>
-      </p:sp>
-      <p:sp>
-        <p:nvSpPr>
-          <p:cNvPr id="9" name="Rounded Rectangle 8"/>
-          <p:cNvSpPr/>
-          <p:nvPr/>
-        </p:nvSpPr>
-        <p:spPr>
-          <a:xfrm>
-            <a:off x="3749040" y="2651760"/>
-            <a:ext cx="1188720" cy="310896"/>
-          </a:xfrm>
-          <a:prstGeom prst="roundRect">
-            <a:avLst>
-              <a:gd name="adj" fmla="val 50000"/>
-            </a:avLst>
-          </a:prstGeom>
-          <a:solidFill>
-            <a:srgbClr val="D03B3B"/>
-          </a:solidFill>
-          <a:ln>
-            <a:noFill/>
-          </a:ln>
-          <a:effectLst/>
-        </p:spPr>
-        <p:style>
-          <a:lnRef idx="1">
-            <a:schemeClr val="accent1"/>
-          </a:lnRef>
-          <a:fillRef idx="3">
-            <a:schemeClr val="accent1"/>
-          </a:fillRef>
-          <a:effectRef idx="2">
-            <a:schemeClr val="accent1"/>
-          </a:effectRef>
-          <a:fontRef idx="minor">
-            <a:schemeClr val="lt1"/>
-          </a:fontRef>
-        </p:style>
-        <p:txBody>
-          <a:bodyPr rtlCol="0" anchor="ctr" lIns="0" rIns="0" tIns="0" bIns="0"/>
-          <a:lstStyle/>
-          <a:p>
-            <a:pPr algn="ctr"/>
-            <a:r>
-              <a:rPr sz="1100" b="1">
-                <a:solidFill>
-                  <a:srgbClr val="FFFFFF"/>
-                </a:solidFill>
-                <a:latin typeface="Calibri"/>
-              </a:rPr>
-              <a:t>Gap</a:t>
-            </a:r>
-          </a:p>
-        </p:txBody>
-      </p:sp>
-      <p:sp>
-        <p:nvSpPr>
-          <p:cNvPr id="10" name="TextBox 9"/>
-          <p:cNvSpPr txBox="1"/>
-          <p:nvPr/>
-        </p:nvSpPr>
-        <p:spPr>
-          <a:xfrm>
-            <a:off x="5669280" y="2011680"/>
-            <a:ext cx="5943600" cy="914400"/>
-          </a:xfrm>
-          <a:prstGeom prst="rect">
-            <a:avLst/>
-          </a:prstGeom>
-          <a:noFill/>
-        </p:spPr>
-        <p:txBody>
-          <a:bodyPr wrap="square" anchor="t" lIns="0" rIns="0" tIns="0" bIns="0">
-            <a:spAutoFit/>
-          </a:bodyPr>
-          <a:lstStyle/>
-          <a:p>
-            <a:pPr algn="l">
-              <a:spcAft>
-                <a:spcPts val="600"/>
-              </a:spcAft>
-            </a:pPr>
-            <a:r>
-              <a:rPr sz="1600" b="0" i="0">
-                <a:solidFill>
-                  <a:srgbClr val="5F6B7A"/>
-                </a:solidFill>
-                <a:latin typeface="Calibri"/>
-              </a:rPr>
-              <a:t>The missing pieces are the ones workers and applicants see first: pay ranges, published criteria, an answer to their questions.</a:t>
-            </a:r>
-          </a:p>
-        </p:txBody>
-      </p:sp>
-      <p:sp>
-        <p:nvSpPr>
-          <p:cNvPr id="11" name="Rounded Rectangle 10"/>
-          <p:cNvSpPr/>
-          <p:nvPr/>
-        </p:nvSpPr>
-        <p:spPr>
-          <a:xfrm>
-            <a:off x="548640" y="3246120"/>
-            <a:ext cx="2602153" cy="1371600"/>
+            <a:off x="548640" y="1920240"/>
+            <a:ext cx="3515258" cy="1828800"/>
           </a:xfrm>
           <a:prstGeom prst="roundRect">
             <a:avLst>
@@ -11665,14 +12669,14 @@
       </p:sp>
       <p:sp>
         <p:nvSpPr>
-          <p:cNvPr id="12" name="TextBox 11"/>
+          <p:cNvPr id="5" name="TextBox 4"/>
           <p:cNvSpPr txBox="1"/>
           <p:nvPr/>
         </p:nvSpPr>
         <p:spPr>
           <a:xfrm>
-            <a:off x="713232" y="3374136"/>
-            <a:ext cx="2272969" cy="1143000"/>
+            <a:off x="777240" y="2148840"/>
+            <a:ext cx="3058058" cy="731520"/>
           </a:xfrm>
           <a:prstGeom prst="rect">
             <a:avLst/>
@@ -11680,26 +12684,10 @@
           <a:noFill/>
         </p:spPr>
         <p:txBody>
-          <a:bodyPr wrap="square" anchor="t" lIns="0" rIns="0" tIns="0" bIns="0">
+          <a:bodyPr wrap="square" anchor="b" lIns="0" rIns="0" tIns="0" bIns="0">
             <a:spAutoFit/>
           </a:bodyPr>
           <a:lstStyle/>
-          <a:p>
-            <a:pPr algn="l">
-              <a:spcAft>
-                <a:spcPts val="300"/>
-              </a:spcAft>
-            </a:pPr>
-            <a:r>
-              <a:rPr sz="1100" b="1" i="0">
-                <a:solidFill>
-                  <a:srgbClr val="5F6B7A"/>
-                </a:solidFill>
-                <a:latin typeface="Calibri"/>
-              </a:rPr>
-              <a:t>Art. 5(1) · Talent Acquisition</a:t>
-            </a:r>
-          </a:p>
           <a:p>
             <a:pPr algn="l">
               <a:spcAft>
@@ -11707,27 +12695,66 @@
               </a:spcAft>
             </a:pPr>
             <a:r>
-              <a:rPr sz="1100" b="0" i="0">
+              <a:rPr sz="4000" b="1" i="0">
+                <a:solidFill>
+                  <a:srgbClr val="EB6834"/>
+                </a:solidFill>
+                <a:latin typeface="Cambria"/>
+              </a:rPr>
+              <a:t>18.0%</a:t>
+            </a:r>
+          </a:p>
+        </p:txBody>
+      </p:sp>
+      <p:sp>
+        <p:nvSpPr>
+          <p:cNvPr id="6" name="TextBox 5"/>
+          <p:cNvSpPr txBox="1"/>
+          <p:nvPr/>
+        </p:nvSpPr>
+        <p:spPr>
+          <a:xfrm>
+            <a:off x="777240" y="2971800"/>
+            <a:ext cx="3058058" cy="731520"/>
+          </a:xfrm>
+          <a:prstGeom prst="rect">
+            <a:avLst/>
+          </a:prstGeom>
+          <a:noFill/>
+        </p:spPr>
+        <p:txBody>
+          <a:bodyPr wrap="square" anchor="t" lIns="0" rIns="0" tIns="0" bIns="0">
+            <a:spAutoFit/>
+          </a:bodyPr>
+          <a:lstStyle/>
+          <a:p>
+            <a:pPr algn="l">
+              <a:spcAft>
+                <a:spcPts val="600"/>
+              </a:spcAft>
+            </a:pPr>
+            <a:r>
+              <a:rPr sz="1400" b="0" i="0">
                 <a:solidFill>
                   <a:srgbClr val="1B2430"/>
                 </a:solidFill>
                 <a:latin typeface="Calibri"/>
               </a:rPr>
-              <a:t>Applicants receive the initial pay or its range, and the relevant collective agreement provisions, before the interview</a:t>
-            </a:r>
-          </a:p>
-        </p:txBody>
-      </p:sp>
-      <p:sp>
-        <p:nvSpPr>
-          <p:cNvPr id="13" name="Rounded Rectangle 12"/>
+              <a:t>Milan's gap on livello retributivo: fixed and continuing pay, the measure the Italian report uses</a:t>
+            </a:r>
+          </a:p>
+        </p:txBody>
+      </p:sp>
+      <p:sp>
+        <p:nvSpPr>
+          <p:cNvPr id="7" name="Rounded Rectangle 6"/>
           <p:cNvSpPr/>
           <p:nvPr/>
         </p:nvSpPr>
         <p:spPr>
           <a:xfrm>
-            <a:off x="3379393" y="3246120"/>
-            <a:ext cx="2602153" cy="1371600"/>
+            <a:off x="4338218" y="1920240"/>
+            <a:ext cx="3515258" cy="1828800"/>
           </a:xfrm>
           <a:prstGeom prst="roundRect">
             <a:avLst>
@@ -11766,14 +12793,14 @@
       </p:sp>
       <p:sp>
         <p:nvSpPr>
-          <p:cNvPr id="14" name="TextBox 13"/>
+          <p:cNvPr id="8" name="TextBox 7"/>
           <p:cNvSpPr txBox="1"/>
           <p:nvPr/>
         </p:nvSpPr>
         <p:spPr>
           <a:xfrm>
-            <a:off x="3543985" y="3374136"/>
-            <a:ext cx="2272969" cy="1143000"/>
+            <a:off x="4566818" y="2148840"/>
+            <a:ext cx="3058058" cy="731520"/>
           </a:xfrm>
           <a:prstGeom prst="rect">
             <a:avLst/>
@@ -11781,26 +12808,10 @@
           <a:noFill/>
         </p:spPr>
         <p:txBody>
-          <a:bodyPr wrap="square" anchor="t" lIns="0" rIns="0" tIns="0" bIns="0">
+          <a:bodyPr wrap="square" anchor="b" lIns="0" rIns="0" tIns="0" bIns="0">
             <a:spAutoFit/>
           </a:bodyPr>
           <a:lstStyle/>
-          <a:p>
-            <a:pPr algn="l">
-              <a:spcAft>
-                <a:spcPts val="300"/>
-              </a:spcAft>
-            </a:pPr>
-            <a:r>
-              <a:rPr sz="1100" b="1" i="0">
-                <a:solidFill>
-                  <a:srgbClr val="5F6B7A"/>
-                </a:solidFill>
-                <a:latin typeface="Calibri"/>
-              </a:rPr>
-              <a:t>Art. 6(1) · Reward</a:t>
-            </a:r>
-          </a:p>
           <a:p>
             <a:pPr algn="l">
               <a:spcAft>
@@ -11808,27 +12819,66 @@
               </a:spcAft>
             </a:pPr>
             <a:r>
-              <a:rPr sz="1100" b="0" i="0">
+              <a:rPr sz="4000" b="1" i="0">
+                <a:solidFill>
+                  <a:srgbClr val="1F3A5F"/>
+                </a:solidFill>
+                <a:latin typeface="Cambria"/>
+              </a:rPr>
+              <a:t>19.7%</a:t>
+            </a:r>
+          </a:p>
+        </p:txBody>
+      </p:sp>
+      <p:sp>
+        <p:nvSpPr>
+          <p:cNvPr id="9" name="TextBox 8"/>
+          <p:cNvSpPr txBox="1"/>
+          <p:nvPr/>
+        </p:nvSpPr>
+        <p:spPr>
+          <a:xfrm>
+            <a:off x="4566818" y="2971800"/>
+            <a:ext cx="3058058" cy="731520"/>
+          </a:xfrm>
+          <a:prstGeom prst="rect">
+            <a:avLst/>
+          </a:prstGeom>
+          <a:noFill/>
+        </p:spPr>
+        <p:txBody>
+          <a:bodyPr wrap="square" anchor="t" lIns="0" rIns="0" tIns="0" bIns="0">
+            <a:spAutoFit/>
+          </a:bodyPr>
+          <a:lstStyle/>
+          <a:p>
+            <a:pPr algn="l">
+              <a:spcAft>
+                <a:spcPts val="600"/>
+              </a:spcAft>
+            </a:pPr>
+            <a:r>
+              <a:rPr sz="1400" b="0" i="0">
                 <a:solidFill>
                   <a:srgbClr val="1B2430"/>
                 </a:solidFill>
                 <a:latin typeface="Calibri"/>
               </a:rPr>
-              <a:t>Workers can easily access the criteria that set pay, pay levels and pay progression</a:t>
-            </a:r>
-          </a:p>
-        </p:txBody>
-      </p:sp>
-      <p:sp>
-        <p:nvSpPr>
-          <p:cNvPr id="15" name="Rounded Rectangle 14"/>
+              <a:t>the same employer on total pay, the Directive's measure</a:t>
+            </a:r>
+          </a:p>
+        </p:txBody>
+      </p:sp>
+      <p:sp>
+        <p:nvSpPr>
+          <p:cNvPr id="10" name="Rounded Rectangle 9"/>
           <p:cNvSpPr/>
           <p:nvPr/>
         </p:nvSpPr>
         <p:spPr>
           <a:xfrm>
-            <a:off x="6210147" y="3246120"/>
-            <a:ext cx="2602153" cy="1371600"/>
+            <a:off x="8127796" y="1920240"/>
+            <a:ext cx="3515258" cy="1828800"/>
           </a:xfrm>
           <a:prstGeom prst="roundRect">
             <a:avLst>
@@ -11867,14 +12917,14 @@
       </p:sp>
       <p:sp>
         <p:nvSpPr>
-          <p:cNvPr id="16" name="TextBox 15"/>
+          <p:cNvPr id="11" name="TextBox 10"/>
           <p:cNvSpPr txBox="1"/>
           <p:nvPr/>
         </p:nvSpPr>
         <p:spPr>
           <a:xfrm>
-            <a:off x="6374739" y="3374136"/>
-            <a:ext cx="2272969" cy="1143000"/>
+            <a:off x="8356396" y="2148840"/>
+            <a:ext cx="3058058" cy="731520"/>
           </a:xfrm>
           <a:prstGeom prst="rect">
             <a:avLst/>
@@ -11882,26 +12932,10 @@
           <a:noFill/>
         </p:spPr>
         <p:txBody>
-          <a:bodyPr wrap="square" anchor="t" lIns="0" rIns="0" tIns="0" bIns="0">
+          <a:bodyPr wrap="square" anchor="b" lIns="0" rIns="0" tIns="0" bIns="0">
             <a:spAutoFit/>
           </a:bodyPr>
           <a:lstStyle/>
-          <a:p>
-            <a:pPr algn="l">
-              <a:spcAft>
-                <a:spcPts val="300"/>
-              </a:spcAft>
-            </a:pPr>
-            <a:r>
-              <a:rPr sz="1100" b="1" i="0">
-                <a:solidFill>
-                  <a:srgbClr val="5F6B7A"/>
-                </a:solidFill>
-                <a:latin typeface="Calibri"/>
-              </a:rPr>
-              <a:t>Art. 7(1) and 7(4) · HR Operations</a:t>
-            </a:r>
-          </a:p>
           <a:p>
             <a:pPr algn="l">
               <a:spcAft>
@@ -11909,27 +12943,66 @@
               </a:spcAft>
             </a:pPr>
             <a:r>
-              <a:rPr sz="1100" b="0" i="0">
+              <a:rPr sz="4000" b="1" i="0">
+                <a:solidFill>
+                  <a:srgbClr val="EB6834"/>
+                </a:solidFill>
+                <a:latin typeface="Cambria"/>
+              </a:rPr>
+              <a:t>3 of 7</a:t>
+            </a:r>
+          </a:p>
+        </p:txBody>
+      </p:sp>
+      <p:sp>
+        <p:nvSpPr>
+          <p:cNvPr id="12" name="TextBox 11"/>
+          <p:cNvSpPr txBox="1"/>
+          <p:nvPr/>
+        </p:nvSpPr>
+        <p:spPr>
+          <a:xfrm>
+            <a:off x="8356396" y="2971800"/>
+            <a:ext cx="3058058" cy="731520"/>
+          </a:xfrm>
+          <a:prstGeom prst="rect">
+            <a:avLst/>
+          </a:prstGeom>
+          <a:noFill/>
+        </p:spPr>
+        <p:txBody>
+          <a:bodyPr wrap="square" anchor="t" lIns="0" rIns="0" tIns="0" bIns="0">
+            <a:spAutoFit/>
+          </a:bodyPr>
+          <a:lstStyle/>
+          <a:p>
+            <a:pPr algn="l">
+              <a:spcAft>
+                <a:spcPts val="600"/>
+              </a:spcAft>
+            </a:pPr>
+            <a:r>
+              <a:rPr sz="1400" b="0" i="0">
                 <a:solidFill>
                   <a:srgbClr val="1B2430"/>
                 </a:solidFill>
                 <a:latin typeface="Calibri"/>
               </a:rPr>
-              <a:t>Workers can request their own pay level and the average pay by sex for their category, answered in writing within two months</a:t>
-            </a:r>
-          </a:p>
-        </p:txBody>
-      </p:sp>
-      <p:sp>
-        <p:nvSpPr>
-          <p:cNvPr id="17" name="Rounded Rectangle 16"/>
+              <a:t>Milan categories to justify or remedy, the same under both measures</a:t>
+            </a:r>
+          </a:p>
+        </p:txBody>
+      </p:sp>
+      <p:sp>
+        <p:nvSpPr>
+          <p:cNvPr id="13" name="Rounded Rectangle 12"/>
           <p:cNvSpPr/>
           <p:nvPr/>
         </p:nvSpPr>
         <p:spPr>
           <a:xfrm>
-            <a:off x="9040901" y="3246120"/>
-            <a:ext cx="2602153" cy="1371600"/>
+            <a:off x="548640" y="4114800"/>
+            <a:ext cx="5349240" cy="2011680"/>
           </a:xfrm>
           <a:prstGeom prst="roundRect">
             <a:avLst>
@@ -11968,14 +13041,14 @@
       </p:sp>
       <p:sp>
         <p:nvSpPr>
-          <p:cNvPr id="18" name="TextBox 17"/>
+          <p:cNvPr id="14" name="TextBox 13"/>
           <p:cNvSpPr txBox="1"/>
           <p:nvPr/>
         </p:nvSpPr>
         <p:spPr>
           <a:xfrm>
-            <a:off x="9205493" y="3374136"/>
-            <a:ext cx="2272969" cy="1143000"/>
+            <a:off x="868680" y="4343400"/>
+            <a:ext cx="4709160" cy="1645920"/>
           </a:xfrm>
           <a:prstGeom prst="rect">
             <a:avLst/>
@@ -11987,22 +13060,6 @@
             <a:spAutoFit/>
           </a:bodyPr>
           <a:lstStyle/>
-          <a:p>
-            <a:pPr algn="l">
-              <a:spcAft>
-                <a:spcPts val="300"/>
-              </a:spcAft>
-            </a:pPr>
-            <a:r>
-              <a:rPr sz="1100" b="1" i="0">
-                <a:solidFill>
-                  <a:srgbClr val="5F6B7A"/>
-                </a:solidFill>
-                <a:latin typeface="Calibri"/>
-              </a:rPr>
-              <a:t>Art. 7(3) · HR Operations</a:t>
-            </a:r>
-          </a:p>
           <a:p>
             <a:pPr algn="l">
               <a:spcAft>
@@ -12010,27 +13067,43 @@
               </a:spcAft>
             </a:pPr>
             <a:r>
-              <a:rPr sz="1100" b="0" i="0">
+              <a:rPr sz="1700" b="1" i="0">
                 <a:solidFill>
                   <a:srgbClr val="1B2430"/>
                 </a:solidFill>
                 <a:latin typeface="Calibri"/>
               </a:rPr>
-              <a:t>Workers are told every year of their right to request that information</a:t>
-            </a:r>
-          </a:p>
-        </p:txBody>
-      </p:sp>
-      <p:sp>
-        <p:nvSpPr>
-          <p:cNvPr id="19" name="Rounded Rectangle 18"/>
+              <a:t>Cat G: 10.5% → 6.1%</a:t>
+            </a:r>
+          </a:p>
+          <a:p>
+            <a:pPr algn="l">
+              <a:spcAft>
+                <a:spcPts val="600"/>
+              </a:spcAft>
+            </a:pPr>
+            <a:r>
+              <a:rPr sz="1400" b="0" i="0">
+                <a:solidFill>
+                  <a:srgbClr val="5F6B7A"/>
+                </a:solidFill>
+                <a:latin typeface="Calibri"/>
+              </a:rPr>
+              <a:t>Bonus and commission leave the Italian 5% test. They stay in items (b) and (d), and in any equal-pay claim.</a:t>
+            </a:r>
+          </a:p>
+        </p:txBody>
+      </p:sp>
+      <p:sp>
+        <p:nvSpPr>
+          <p:cNvPr id="15" name="Rounded Rectangle 14"/>
           <p:cNvSpPr/>
           <p:nvPr/>
         </p:nvSpPr>
         <p:spPr>
           <a:xfrm>
-            <a:off x="548640" y="4800600"/>
-            <a:ext cx="2602153" cy="1371600"/>
+            <a:off x="6291072" y="4114800"/>
+            <a:ext cx="5349240" cy="2011680"/>
           </a:xfrm>
           <a:prstGeom prst="roundRect">
             <a:avLst>
@@ -12069,14 +13142,14 @@
       </p:sp>
       <p:sp>
         <p:nvSpPr>
-          <p:cNvPr id="20" name="TextBox 19"/>
+          <p:cNvPr id="16" name="TextBox 15"/>
           <p:cNvSpPr txBox="1"/>
           <p:nvPr/>
         </p:nvSpPr>
         <p:spPr>
           <a:xfrm>
-            <a:off x="713232" y="4928616"/>
-            <a:ext cx="2272969" cy="1143000"/>
+            <a:off x="6611112" y="4343400"/>
+            <a:ext cx="4709160" cy="1645920"/>
           </a:xfrm>
           <a:prstGeom prst="rect">
             <a:avLst/>
@@ -12088,22 +13161,6 @@
             <a:spAutoFit/>
           </a:bodyPr>
           <a:lstStyle/>
-          <a:p>
-            <a:pPr algn="l">
-              <a:spcAft>
-                <a:spcPts val="300"/>
-              </a:spcAft>
-            </a:pPr>
-            <a:r>
-              <a:rPr sz="1100" b="1" i="0">
-                <a:solidFill>
-                  <a:srgbClr val="5F6B7A"/>
-                </a:solidFill>
-                <a:latin typeface="Calibri"/>
-              </a:rPr>
-              <a:t>Art. 8 · HR Operations</a:t>
-            </a:r>
-          </a:p>
           <a:p>
             <a:pPr algn="l">
               <a:spcAft>
@@ -12111,98 +13168,13 @@
               </a:spcAft>
             </a:pPr>
             <a:r>
-              <a:rPr sz="1100" b="0" i="0">
+              <a:rPr sz="1700" b="1" i="0">
                 <a:solidFill>
                   <a:srgbClr val="1B2430"/>
                 </a:solidFill>
                 <a:latin typeface="Calibri"/>
               </a:rPr>
-              <a:t>Information for workers and applicants is accessible to persons with disabilities</a:t>
-            </a:r>
-          </a:p>
-        </p:txBody>
-      </p:sp>
-      <p:sp>
-        <p:nvSpPr>
-          <p:cNvPr id="21" name="Rounded Rectangle 20"/>
-          <p:cNvSpPr/>
-          <p:nvPr/>
-        </p:nvSpPr>
-        <p:spPr>
-          <a:xfrm>
-            <a:off x="3379393" y="4800600"/>
-            <a:ext cx="2602153" cy="1371600"/>
-          </a:xfrm>
-          <a:prstGeom prst="roundRect">
-            <a:avLst>
-              <a:gd name="adj" fmla="val 8000"/>
-            </a:avLst>
-          </a:prstGeom>
-          <a:solidFill>
-            <a:srgbClr val="F1F4F8"/>
-          </a:solidFill>
-          <a:ln>
-            <a:noFill/>
-          </a:ln>
-          <a:effectLst/>
-        </p:spPr>
-        <p:style>
-          <a:lnRef idx="1">
-            <a:schemeClr val="accent1"/>
-          </a:lnRef>
-          <a:fillRef idx="3">
-            <a:schemeClr val="accent1"/>
-          </a:fillRef>
-          <a:effectRef idx="2">
-            <a:schemeClr val="accent1"/>
-          </a:effectRef>
-          <a:fontRef idx="minor">
-            <a:schemeClr val="lt1"/>
-          </a:fontRef>
-        </p:style>
-        <p:txBody>
-          <a:bodyPr rtlCol="0" anchor="ctr"/>
-          <a:lstStyle/>
-          <a:p>
-            <a:pPr algn="ctr"/>
-          </a:p>
-        </p:txBody>
-      </p:sp>
-      <p:sp>
-        <p:nvSpPr>
-          <p:cNvPr id="22" name="TextBox 21"/>
-          <p:cNvSpPr txBox="1"/>
-          <p:nvPr/>
-        </p:nvSpPr>
-        <p:spPr>
-          <a:xfrm>
-            <a:off x="3543985" y="4928616"/>
-            <a:ext cx="2272969" cy="1143000"/>
-          </a:xfrm>
-          <a:prstGeom prst="rect">
-            <a:avLst/>
-          </a:prstGeom>
-          <a:noFill/>
-        </p:spPr>
-        <p:txBody>
-          <a:bodyPr wrap="square" anchor="t" lIns="0" rIns="0" tIns="0" bIns="0">
-            <a:spAutoFit/>
-          </a:bodyPr>
-          <a:lstStyle/>
-          <a:p>
-            <a:pPr algn="l">
-              <a:spcAft>
-                <a:spcPts val="300"/>
-              </a:spcAft>
-            </a:pPr>
-            <a:r>
-              <a:rPr sz="1100" b="1" i="0">
-                <a:solidFill>
-                  <a:srgbClr val="5F6B7A"/>
-                </a:solidFill>
-                <a:latin typeface="Calibri"/>
-              </a:rPr>
-              <a:t>Art. 9(6) · HR Director</a:t>
+              <a:t>Cat A: 4.1% → 6.1%</a:t>
             </a:r>
           </a:p>
           <a:p>
@@ -12212,73 +13184,27 @@
               </a:spcAft>
             </a:pPr>
             <a:r>
-              <a:rPr sz="1100" b="0" i="0">
-                <a:solidFill>
-                  <a:srgbClr val="1B2430"/>
+              <a:rPr sz="1400" b="0" i="0">
+                <a:solidFill>
+                  <a:srgbClr val="5F6B7A"/>
                 </a:solidFill>
                 <a:latin typeface="Calibri"/>
               </a:rPr>
-              <a:t>Management confirms the accuracy of the report after consulting workers' representatives, who can see the method</a:t>
-            </a:r>
-          </a:p>
-        </p:txBody>
-      </p:sp>
-      <p:sp>
-        <p:nvSpPr>
-          <p:cNvPr id="23" name="Rounded Rectangle 22"/>
-          <p:cNvSpPr/>
-          <p:nvPr/>
-        </p:nvSpPr>
-        <p:spPr>
-          <a:xfrm>
-            <a:off x="6210147" y="4800600"/>
-            <a:ext cx="2602153" cy="1371600"/>
-          </a:xfrm>
-          <a:prstGeom prst="roundRect">
-            <a:avLst>
-              <a:gd name="adj" fmla="val 8000"/>
-            </a:avLst>
-          </a:prstGeom>
-          <a:solidFill>
-            <a:srgbClr val="F1F4F8"/>
-          </a:solidFill>
-          <a:ln>
-            <a:noFill/>
-          </a:ln>
-          <a:effectLst/>
-        </p:spPr>
-        <p:style>
-          <a:lnRef idx="1">
-            <a:schemeClr val="accent1"/>
-          </a:lnRef>
-          <a:fillRef idx="3">
-            <a:schemeClr val="accent1"/>
-          </a:fillRef>
-          <a:effectRef idx="2">
-            <a:schemeClr val="accent1"/>
-          </a:effectRef>
-          <a:fontRef idx="minor">
-            <a:schemeClr val="lt1"/>
-          </a:fontRef>
-        </p:style>
-        <p:txBody>
-          <a:bodyPr rtlCol="0" anchor="ctr"/>
-          <a:lstStyle/>
-          <a:p>
-            <a:pPr algn="ctr"/>
-          </a:p>
-        </p:txBody>
-      </p:sp>
-      <p:sp>
-        <p:nvSpPr>
-          <p:cNvPr id="24" name="TextBox 23"/>
+              <a:t>Components were offsetting a gap in fixed pay. Without them, the justification has to be about base pay and allowances.</a:t>
+            </a:r>
+          </a:p>
+        </p:txBody>
+      </p:sp>
+      <p:sp>
+        <p:nvSpPr>
+          <p:cNvPr id="17" name="TextBox 16"/>
           <p:cNvSpPr txBox="1"/>
           <p:nvPr/>
         </p:nvSpPr>
         <p:spPr>
           <a:xfrm>
-            <a:off x="6374739" y="4928616"/>
-            <a:ext cx="2272969" cy="1143000"/>
+            <a:off x="548640" y="6446520"/>
+            <a:ext cx="8229600" cy="274320"/>
           </a:xfrm>
           <a:prstGeom prst="rect">
             <a:avLst/>
@@ -12290,22 +13216,6 @@
             <a:spAutoFit/>
           </a:bodyPr>
           <a:lstStyle/>
-          <a:p>
-            <a:pPr algn="l">
-              <a:spcAft>
-                <a:spcPts val="300"/>
-              </a:spcAft>
-            </a:pPr>
-            <a:r>
-              <a:rPr sz="1100" b="1" i="0">
-                <a:solidFill>
-                  <a:srgbClr val="5F6B7A"/>
-                </a:solidFill>
-                <a:latin typeface="Calibri"/>
-              </a:rPr>
-              <a:t>Art. 9(9) · HR Operations</a:t>
-            </a:r>
-          </a:p>
           <a:p>
             <a:pPr algn="l">
               <a:spcAft>
@@ -12313,51 +13223,12 @@
               </a:spcAft>
             </a:pPr>
             <a:r>
-              <a:rPr sz="1100" b="0" i="0">
-                <a:solidFill>
-                  <a:srgbClr val="1B2430"/>
+              <a:rPr sz="1000" b="0" i="0">
+                <a:solidFill>
+                  <a:srgbClr val="5F6B7A"/>
                 </a:solidFill>
                 <a:latin typeface="Calibri"/>
               </a:rPr>
-              <a:t>Pay gaps by category of workers are provided to all workers and their representatives</a:t>
-            </a:r>
-          </a:p>
-        </p:txBody>
-      </p:sp>
-      <p:sp>
-        <p:nvSpPr>
-          <p:cNvPr id="25" name="TextBox 24"/>
-          <p:cNvSpPr txBox="1"/>
-          <p:nvPr/>
-        </p:nvSpPr>
-        <p:spPr>
-          <a:xfrm>
-            <a:off x="548640" y="6446520"/>
-            <a:ext cx="8229600" cy="274320"/>
-          </a:xfrm>
-          <a:prstGeom prst="rect">
-            <a:avLst/>
-          </a:prstGeom>
-          <a:noFill/>
-        </p:spPr>
-        <p:txBody>
-          <a:bodyPr wrap="square" anchor="t" lIns="0" rIns="0" tIns="0" bIns="0">
-            <a:spAutoFit/>
-          </a:bodyPr>
-          <a:lstStyle/>
-          <a:p>
-            <a:pPr algn="l">
-              <a:spcAft>
-                <a:spcPts val="600"/>
-              </a:spcAft>
-            </a:pPr>
-            <a:r>
-              <a:rPr sz="1000" b="0" i="0">
-                <a:solidFill>
-                  <a:srgbClr val="5F6B7A"/>
-                </a:solidFill>
-                <a:latin typeface="Calibri"/>
-              </a:rPr>
               <a:t>Pay transparency readiness · dry run on synthetic data · not legal advice</a:t>
             </a:r>
           </a:p>
@@ -12365,7 +13236,7 @@
       </p:sp>
       <p:sp>
         <p:nvSpPr>
-          <p:cNvPr id="26" name="TextBox 25"/>
+          <p:cNvPr id="18" name="TextBox 17"/>
           <p:cNvSpPr txBox="1"/>
           <p:nvPr/>
         </p:nvSpPr>
@@ -12437,7 +13308,7 @@
         <p:spPr>
           <a:xfrm>
             <a:off x="548640" y="411480"/>
-            <a:ext cx="1197864" cy="310896"/>
+            <a:ext cx="2075688" cy="310896"/>
           </a:xfrm>
           <a:prstGeom prst="roundRect">
             <a:avLst>
@@ -12478,7 +13349,7 @@
                 </a:solidFill>
                 <a:latin typeface="Calibri"/>
               </a:rPr>
-              <a:t>The plan</a:t>
+              <a:t>Articles 4 to 12</a:t>
             </a:r>
           </a:p>
         </p:txBody>
@@ -12517,21 +13388,342 @@
                 </a:solidFill>
                 <a:latin typeface="Cambria"/>
               </a:rPr>
-              <a:t>The next 90 days</a:t>
-            </a:r>
-          </a:p>
-        </p:txBody>
-      </p:sp>
-      <p:sp>
-        <p:nvSpPr>
-          <p:cNvPr id="4" name="Rounded Rectangle 3"/>
+              <a:t>Most of what workers will see is not built yet</a:t>
+            </a:r>
+          </a:p>
+        </p:txBody>
+      </p:sp>
+      <p:sp>
+        <p:nvSpPr>
+          <p:cNvPr id="4" name="TextBox 3"/>
+          <p:cNvSpPr txBox="1"/>
+          <p:nvPr/>
+        </p:nvSpPr>
+        <p:spPr>
+          <a:xfrm>
+            <a:off x="548640" y="1874519"/>
+            <a:ext cx="1371600" cy="731520"/>
+          </a:xfrm>
+          <a:prstGeom prst="rect">
+            <a:avLst/>
+          </a:prstGeom>
+          <a:noFill/>
+        </p:spPr>
+        <p:txBody>
+          <a:bodyPr wrap="square" anchor="t" lIns="0" rIns="0" tIns="0" bIns="0">
+            <a:spAutoFit/>
+          </a:bodyPr>
+          <a:lstStyle/>
+          <a:p>
+            <a:pPr algn="l">
+              <a:spcAft>
+                <a:spcPts val="600"/>
+              </a:spcAft>
+            </a:pPr>
+            <a:r>
+              <a:rPr sz="4000" b="1" i="0">
+                <a:solidFill>
+                  <a:srgbClr val="1B2430"/>
+                </a:solidFill>
+                <a:latin typeface="Cambria"/>
+              </a:rPr>
+              <a:t>1</a:t>
+            </a:r>
+          </a:p>
+        </p:txBody>
+      </p:sp>
+      <p:sp>
+        <p:nvSpPr>
+          <p:cNvPr id="5" name="Rounded Rectangle 4"/>
           <p:cNvSpPr/>
           <p:nvPr/>
         </p:nvSpPr>
         <p:spPr>
           <a:xfrm>
-            <a:off x="548640" y="1920240"/>
-            <a:ext cx="3515258" cy="1874519"/>
+            <a:off x="548640" y="2651760"/>
+            <a:ext cx="1188720" cy="310896"/>
+          </a:xfrm>
+          <a:prstGeom prst="roundRect">
+            <a:avLst>
+              <a:gd name="adj" fmla="val 50000"/>
+            </a:avLst>
+          </a:prstGeom>
+          <a:solidFill>
+            <a:srgbClr val="0CA30C"/>
+          </a:solidFill>
+          <a:ln>
+            <a:noFill/>
+          </a:ln>
+          <a:effectLst/>
+        </p:spPr>
+        <p:style>
+          <a:lnRef idx="1">
+            <a:schemeClr val="accent1"/>
+          </a:lnRef>
+          <a:fillRef idx="3">
+            <a:schemeClr val="accent1"/>
+          </a:fillRef>
+          <a:effectRef idx="2">
+            <a:schemeClr val="accent1"/>
+          </a:effectRef>
+          <a:fontRef idx="minor">
+            <a:schemeClr val="lt1"/>
+          </a:fontRef>
+        </p:style>
+        <p:txBody>
+          <a:bodyPr rtlCol="0" anchor="ctr" lIns="0" rIns="0" tIns="0" bIns="0"/>
+          <a:lstStyle/>
+          <a:p>
+            <a:pPr algn="ctr"/>
+            <a:r>
+              <a:rPr sz="1100" b="1">
+                <a:solidFill>
+                  <a:srgbClr val="FFFFFF"/>
+                </a:solidFill>
+                <a:latin typeface="Calibri"/>
+              </a:rPr>
+              <a:t>Ready</a:t>
+            </a:r>
+          </a:p>
+        </p:txBody>
+      </p:sp>
+      <p:sp>
+        <p:nvSpPr>
+          <p:cNvPr id="6" name="TextBox 5"/>
+          <p:cNvSpPr txBox="1"/>
+          <p:nvPr/>
+        </p:nvSpPr>
+        <p:spPr>
+          <a:xfrm>
+            <a:off x="2148840" y="1874519"/>
+            <a:ext cx="1371600" cy="731520"/>
+          </a:xfrm>
+          <a:prstGeom prst="rect">
+            <a:avLst/>
+          </a:prstGeom>
+          <a:noFill/>
+        </p:spPr>
+        <p:txBody>
+          <a:bodyPr wrap="square" anchor="t" lIns="0" rIns="0" tIns="0" bIns="0">
+            <a:spAutoFit/>
+          </a:bodyPr>
+          <a:lstStyle/>
+          <a:p>
+            <a:pPr algn="l">
+              <a:spcAft>
+                <a:spcPts val="600"/>
+              </a:spcAft>
+            </a:pPr>
+            <a:r>
+              <a:rPr sz="4000" b="1" i="0">
+                <a:solidFill>
+                  <a:srgbClr val="1B2430"/>
+                </a:solidFill>
+                <a:latin typeface="Cambria"/>
+              </a:rPr>
+              <a:t>6</a:t>
+            </a:r>
+          </a:p>
+        </p:txBody>
+      </p:sp>
+      <p:sp>
+        <p:nvSpPr>
+          <p:cNvPr id="7" name="Rounded Rectangle 6"/>
+          <p:cNvSpPr/>
+          <p:nvPr/>
+        </p:nvSpPr>
+        <p:spPr>
+          <a:xfrm>
+            <a:off x="2148840" y="2651760"/>
+            <a:ext cx="1188720" cy="310896"/>
+          </a:xfrm>
+          <a:prstGeom prst="roundRect">
+            <a:avLst>
+              <a:gd name="adj" fmla="val 50000"/>
+            </a:avLst>
+          </a:prstGeom>
+          <a:solidFill>
+            <a:srgbClr val="FAB219"/>
+          </a:solidFill>
+          <a:ln>
+            <a:noFill/>
+          </a:ln>
+          <a:effectLst/>
+        </p:spPr>
+        <p:style>
+          <a:lnRef idx="1">
+            <a:schemeClr val="accent1"/>
+          </a:lnRef>
+          <a:fillRef idx="3">
+            <a:schemeClr val="accent1"/>
+          </a:fillRef>
+          <a:effectRef idx="2">
+            <a:schemeClr val="accent1"/>
+          </a:effectRef>
+          <a:fontRef idx="minor">
+            <a:schemeClr val="lt1"/>
+          </a:fontRef>
+        </p:style>
+        <p:txBody>
+          <a:bodyPr rtlCol="0" anchor="ctr" lIns="0" rIns="0" tIns="0" bIns="0"/>
+          <a:lstStyle/>
+          <a:p>
+            <a:pPr algn="ctr"/>
+            <a:r>
+              <a:rPr sz="1100" b="1">
+                <a:solidFill>
+                  <a:srgbClr val="1B2430"/>
+                </a:solidFill>
+                <a:latin typeface="Calibri"/>
+              </a:rPr>
+              <a:t>Partial</a:t>
+            </a:r>
+          </a:p>
+        </p:txBody>
+      </p:sp>
+      <p:sp>
+        <p:nvSpPr>
+          <p:cNvPr id="8" name="TextBox 7"/>
+          <p:cNvSpPr txBox="1"/>
+          <p:nvPr/>
+        </p:nvSpPr>
+        <p:spPr>
+          <a:xfrm>
+            <a:off x="3749040" y="1874519"/>
+            <a:ext cx="1371600" cy="731520"/>
+          </a:xfrm>
+          <a:prstGeom prst="rect">
+            <a:avLst/>
+          </a:prstGeom>
+          <a:noFill/>
+        </p:spPr>
+        <p:txBody>
+          <a:bodyPr wrap="square" anchor="t" lIns="0" rIns="0" tIns="0" bIns="0">
+            <a:spAutoFit/>
+          </a:bodyPr>
+          <a:lstStyle/>
+          <a:p>
+            <a:pPr algn="l">
+              <a:spcAft>
+                <a:spcPts val="600"/>
+              </a:spcAft>
+            </a:pPr>
+            <a:r>
+              <a:rPr sz="4000" b="1" i="0">
+                <a:solidFill>
+                  <a:srgbClr val="1B2430"/>
+                </a:solidFill>
+                <a:latin typeface="Cambria"/>
+              </a:rPr>
+              <a:t>7</a:t>
+            </a:r>
+          </a:p>
+        </p:txBody>
+      </p:sp>
+      <p:sp>
+        <p:nvSpPr>
+          <p:cNvPr id="9" name="Rounded Rectangle 8"/>
+          <p:cNvSpPr/>
+          <p:nvPr/>
+        </p:nvSpPr>
+        <p:spPr>
+          <a:xfrm>
+            <a:off x="3749040" y="2651760"/>
+            <a:ext cx="1188720" cy="310896"/>
+          </a:xfrm>
+          <a:prstGeom prst="roundRect">
+            <a:avLst>
+              <a:gd name="adj" fmla="val 50000"/>
+            </a:avLst>
+          </a:prstGeom>
+          <a:solidFill>
+            <a:srgbClr val="D03B3B"/>
+          </a:solidFill>
+          <a:ln>
+            <a:noFill/>
+          </a:ln>
+          <a:effectLst/>
+        </p:spPr>
+        <p:style>
+          <a:lnRef idx="1">
+            <a:schemeClr val="accent1"/>
+          </a:lnRef>
+          <a:fillRef idx="3">
+            <a:schemeClr val="accent1"/>
+          </a:fillRef>
+          <a:effectRef idx="2">
+            <a:schemeClr val="accent1"/>
+          </a:effectRef>
+          <a:fontRef idx="minor">
+            <a:schemeClr val="lt1"/>
+          </a:fontRef>
+        </p:style>
+        <p:txBody>
+          <a:bodyPr rtlCol="0" anchor="ctr" lIns="0" rIns="0" tIns="0" bIns="0"/>
+          <a:lstStyle/>
+          <a:p>
+            <a:pPr algn="ctr"/>
+            <a:r>
+              <a:rPr sz="1100" b="1">
+                <a:solidFill>
+                  <a:srgbClr val="FFFFFF"/>
+                </a:solidFill>
+                <a:latin typeface="Calibri"/>
+              </a:rPr>
+              <a:t>Gap</a:t>
+            </a:r>
+          </a:p>
+        </p:txBody>
+      </p:sp>
+      <p:sp>
+        <p:nvSpPr>
+          <p:cNvPr id="10" name="TextBox 9"/>
+          <p:cNvSpPr txBox="1"/>
+          <p:nvPr/>
+        </p:nvSpPr>
+        <p:spPr>
+          <a:xfrm>
+            <a:off x="5669280" y="2011680"/>
+            <a:ext cx="5943600" cy="914400"/>
+          </a:xfrm>
+          <a:prstGeom prst="rect">
+            <a:avLst/>
+          </a:prstGeom>
+          <a:noFill/>
+        </p:spPr>
+        <p:txBody>
+          <a:bodyPr wrap="square" anchor="t" lIns="0" rIns="0" tIns="0" bIns="0">
+            <a:spAutoFit/>
+          </a:bodyPr>
+          <a:lstStyle/>
+          <a:p>
+            <a:pPr algn="l">
+              <a:spcAft>
+                <a:spcPts val="600"/>
+              </a:spcAft>
+            </a:pPr>
+            <a:r>
+              <a:rPr sz="1600" b="0" i="0">
+                <a:solidFill>
+                  <a:srgbClr val="5F6B7A"/>
+                </a:solidFill>
+                <a:latin typeface="Calibri"/>
+              </a:rPr>
+              <a:t>The missing pieces are the ones workers and applicants see first: pay ranges, published criteria, an answer to their questions.</a:t>
+            </a:r>
+          </a:p>
+        </p:txBody>
+      </p:sp>
+      <p:sp>
+        <p:nvSpPr>
+          <p:cNvPr id="11" name="Rounded Rectangle 10"/>
+          <p:cNvSpPr/>
+          <p:nvPr/>
+        </p:nvSpPr>
+        <p:spPr>
+          <a:xfrm>
+            <a:off x="548640" y="3246120"/>
+            <a:ext cx="2602153" cy="1371600"/>
           </a:xfrm>
           <a:prstGeom prst="roundRect">
             <a:avLst>
@@ -12570,66 +13762,14 @@
       </p:sp>
       <p:sp>
         <p:nvSpPr>
-          <p:cNvPr id="5" name="Oval 4"/>
-          <p:cNvSpPr/>
-          <p:nvPr/>
-        </p:nvSpPr>
-        <p:spPr>
-          <a:xfrm>
-            <a:off x="822960" y="2194560"/>
-            <a:ext cx="457200" cy="457200"/>
-          </a:xfrm>
-          <a:prstGeom prst="ellipse">
-            <a:avLst/>
-          </a:prstGeom>
-          <a:solidFill>
-            <a:srgbClr val="1F3A5F"/>
-          </a:solidFill>
-          <a:ln>
-            <a:noFill/>
-          </a:ln>
-        </p:spPr>
-        <p:style>
-          <a:lnRef idx="1">
-            <a:schemeClr val="accent1"/>
-          </a:lnRef>
-          <a:fillRef idx="3">
-            <a:schemeClr val="accent1"/>
-          </a:fillRef>
-          <a:effectRef idx="2">
-            <a:schemeClr val="accent1"/>
-          </a:effectRef>
-          <a:fontRef idx="minor">
-            <a:schemeClr val="lt1"/>
-          </a:fontRef>
-        </p:style>
-        <p:txBody>
-          <a:bodyPr rtlCol="0" anchor="ctr" lIns="0" rIns="0" tIns="0" bIns="0"/>
-          <a:lstStyle/>
-          <a:p>
-            <a:pPr algn="ctr"/>
-            <a:r>
-              <a:rPr sz="1600" b="1">
-                <a:solidFill>
-                  <a:srgbClr val="FFFFFF"/>
-                </a:solidFill>
-                <a:latin typeface="Calibri"/>
-              </a:rPr>
-              <a:t>1</a:t>
-            </a:r>
-          </a:p>
-        </p:txBody>
-      </p:sp>
-      <p:sp>
-        <p:nvSpPr>
-          <p:cNvPr id="6" name="TextBox 5"/>
+          <p:cNvPr id="12" name="TextBox 11"/>
           <p:cNvSpPr txBox="1"/>
           <p:nvPr/>
         </p:nvSpPr>
         <p:spPr>
           <a:xfrm>
-            <a:off x="822960" y="2743200"/>
-            <a:ext cx="2966618" cy="365760"/>
+            <a:off x="713232" y="3374136"/>
+            <a:ext cx="2272969" cy="1143000"/>
           </a:xfrm>
           <a:prstGeom prst="rect">
             <a:avLst/>
@@ -12641,6 +13781,22 @@
             <a:spAutoFit/>
           </a:bodyPr>
           <a:lstStyle/>
+          <a:p>
+            <a:pPr algn="l">
+              <a:spcAft>
+                <a:spcPts val="300"/>
+              </a:spcAft>
+            </a:pPr>
+            <a:r>
+              <a:rPr sz="1100" b="1" i="0">
+                <a:solidFill>
+                  <a:srgbClr val="5F6B7A"/>
+                </a:solidFill>
+                <a:latin typeface="Calibri"/>
+              </a:rPr>
+              <a:t>Art. 5(1) · Talent Acquisition</a:t>
+            </a:r>
+          </a:p>
           <a:p>
             <a:pPr algn="l">
               <a:spcAft>
@@ -12648,66 +13804,27 @@
               </a:spcAft>
             </a:pPr>
             <a:r>
-              <a:rPr sz="1600" b="1" i="0">
+              <a:rPr sz="1100" b="0" i="0">
                 <a:solidFill>
                   <a:srgbClr val="1B2430"/>
                 </a:solidFill>
                 <a:latin typeface="Calibri"/>
               </a:rPr>
-              <a:t>Agree job evaluation</a:t>
-            </a:r>
-          </a:p>
-        </p:txBody>
-      </p:sp>
-      <p:sp>
-        <p:nvSpPr>
-          <p:cNvPr id="7" name="TextBox 6"/>
-          <p:cNvSpPr txBox="1"/>
-          <p:nvPr/>
-        </p:nvSpPr>
-        <p:spPr>
-          <a:xfrm>
-            <a:off x="822960" y="3127248"/>
-            <a:ext cx="2966618" cy="640080"/>
-          </a:xfrm>
-          <a:prstGeom prst="rect">
-            <a:avLst/>
-          </a:prstGeom>
-          <a:noFill/>
-        </p:spPr>
-        <p:txBody>
-          <a:bodyPr wrap="square" anchor="t" lIns="0" rIns="0" tIns="0" bIns="0">
-            <a:spAutoFit/>
-          </a:bodyPr>
-          <a:lstStyle/>
-          <a:p>
-            <a:pPr algn="l">
-              <a:spcAft>
-                <a:spcPts val="600"/>
-              </a:spcAft>
-            </a:pPr>
-            <a:r>
-              <a:rPr sz="1300" b="0" i="0">
-                <a:solidFill>
-                  <a:srgbClr val="5F6B7A"/>
-                </a:solidFill>
-                <a:latin typeface="Calibri"/>
-              </a:rPr>
-              <a:t>With workers' representatives, starting from the Italian collective agreement.</a:t>
-            </a:r>
-          </a:p>
-        </p:txBody>
-      </p:sp>
-      <p:sp>
-        <p:nvSpPr>
-          <p:cNvPr id="8" name="Rounded Rectangle 7"/>
+              <a:t>Applicants receive the initial pay or its range, and the relevant collective agreement provisions, before the interview</a:t>
+            </a:r>
+          </a:p>
+        </p:txBody>
+      </p:sp>
+      <p:sp>
+        <p:nvSpPr>
+          <p:cNvPr id="13" name="Rounded Rectangle 12"/>
           <p:cNvSpPr/>
           <p:nvPr/>
         </p:nvSpPr>
         <p:spPr>
           <a:xfrm>
-            <a:off x="4338218" y="1920240"/>
-            <a:ext cx="3515258" cy="1874519"/>
+            <a:off x="3379393" y="3246120"/>
+            <a:ext cx="2602153" cy="1371600"/>
           </a:xfrm>
           <a:prstGeom prst="roundRect">
             <a:avLst>
@@ -12746,66 +13863,14 @@
       </p:sp>
       <p:sp>
         <p:nvSpPr>
-          <p:cNvPr id="9" name="Oval 8"/>
-          <p:cNvSpPr/>
-          <p:nvPr/>
-        </p:nvSpPr>
-        <p:spPr>
-          <a:xfrm>
-            <a:off x="4612538" y="2194560"/>
-            <a:ext cx="457200" cy="457200"/>
-          </a:xfrm>
-          <a:prstGeom prst="ellipse">
-            <a:avLst/>
-          </a:prstGeom>
-          <a:solidFill>
-            <a:srgbClr val="1F3A5F"/>
-          </a:solidFill>
-          <a:ln>
-            <a:noFill/>
-          </a:ln>
-        </p:spPr>
-        <p:style>
-          <a:lnRef idx="1">
-            <a:schemeClr val="accent1"/>
-          </a:lnRef>
-          <a:fillRef idx="3">
-            <a:schemeClr val="accent1"/>
-          </a:fillRef>
-          <a:effectRef idx="2">
-            <a:schemeClr val="accent1"/>
-          </a:effectRef>
-          <a:fontRef idx="minor">
-            <a:schemeClr val="lt1"/>
-          </a:fontRef>
-        </p:style>
-        <p:txBody>
-          <a:bodyPr rtlCol="0" anchor="ctr" lIns="0" rIns="0" tIns="0" bIns="0"/>
-          <a:lstStyle/>
-          <a:p>
-            <a:pPr algn="ctr"/>
-            <a:r>
-              <a:rPr sz="1600" b="1">
-                <a:solidFill>
-                  <a:srgbClr val="FFFFFF"/>
-                </a:solidFill>
-                <a:latin typeface="Calibri"/>
-              </a:rPr>
-              <a:t>2</a:t>
-            </a:r>
-          </a:p>
-        </p:txBody>
-      </p:sp>
-      <p:sp>
-        <p:nvSpPr>
-          <p:cNvPr id="10" name="TextBox 9"/>
+          <p:cNvPr id="14" name="TextBox 13"/>
           <p:cNvSpPr txBox="1"/>
           <p:nvPr/>
         </p:nvSpPr>
         <p:spPr>
           <a:xfrm>
-            <a:off x="4612538" y="2743200"/>
-            <a:ext cx="2966618" cy="365760"/>
+            <a:off x="3543985" y="3374136"/>
+            <a:ext cx="2272969" cy="1143000"/>
           </a:xfrm>
           <a:prstGeom prst="rect">
             <a:avLst/>
@@ -12817,6 +13882,22 @@
             <a:spAutoFit/>
           </a:bodyPr>
           <a:lstStyle/>
+          <a:p>
+            <a:pPr algn="l">
+              <a:spcAft>
+                <a:spcPts val="300"/>
+              </a:spcAft>
+            </a:pPr>
+            <a:r>
+              <a:rPr sz="1100" b="1" i="0">
+                <a:solidFill>
+                  <a:srgbClr val="5F6B7A"/>
+                </a:solidFill>
+                <a:latin typeface="Calibri"/>
+              </a:rPr>
+              <a:t>Art. 6(1) · Reward</a:t>
+            </a:r>
+          </a:p>
           <a:p>
             <a:pPr algn="l">
               <a:spcAft>
@@ -12824,66 +13905,27 @@
               </a:spcAft>
             </a:pPr>
             <a:r>
-              <a:rPr sz="1600" b="1" i="0">
+              <a:rPr sz="1100" b="0" i="0">
                 <a:solidFill>
                   <a:srgbClr val="1B2430"/>
                 </a:solidFill>
                 <a:latin typeface="Calibri"/>
               </a:rPr>
-              <a:t>Justify or budget flags</a:t>
-            </a:r>
-          </a:p>
-        </p:txBody>
-      </p:sp>
-      <p:sp>
-        <p:nvSpPr>
-          <p:cNvPr id="11" name="TextBox 10"/>
-          <p:cNvSpPr txBox="1"/>
-          <p:nvPr/>
-        </p:nvSpPr>
-        <p:spPr>
-          <a:xfrm>
-            <a:off x="4612538" y="3127248"/>
-            <a:ext cx="2966618" cy="640080"/>
-          </a:xfrm>
-          <a:prstGeom prst="rect">
-            <a:avLst/>
-          </a:prstGeom>
-          <a:noFill/>
-        </p:spPr>
-        <p:txBody>
-          <a:bodyPr wrap="square" anchor="t" lIns="0" rIns="0" tIns="0" bIns="0">
-            <a:spAutoFit/>
-          </a:bodyPr>
-          <a:lstStyle/>
-          <a:p>
-            <a:pPr algn="l">
-              <a:spcAft>
-                <a:spcPts val="600"/>
-              </a:spcAft>
-            </a:pPr>
-            <a:r>
-              <a:rPr sz="1300" b="0" i="0">
-                <a:solidFill>
-                  <a:srgbClr val="5F6B7A"/>
-                </a:solidFill>
-                <a:latin typeface="Calibri"/>
-              </a:rPr>
-              <a:t>Most expensive first: a documented, gender-neutral reason or a remedy.</a:t>
-            </a:r>
-          </a:p>
-        </p:txBody>
-      </p:sp>
-      <p:sp>
-        <p:nvSpPr>
-          <p:cNvPr id="12" name="Rounded Rectangle 11"/>
+              <a:t>Workers can easily access the criteria that set pay, pay levels and pay progression</a:t>
+            </a:r>
+          </a:p>
+        </p:txBody>
+      </p:sp>
+      <p:sp>
+        <p:nvSpPr>
+          <p:cNvPr id="15" name="Rounded Rectangle 14"/>
           <p:cNvSpPr/>
           <p:nvPr/>
         </p:nvSpPr>
         <p:spPr>
           <a:xfrm>
-            <a:off x="8127796" y="1920240"/>
-            <a:ext cx="3515258" cy="1874519"/>
+            <a:off x="6210147" y="3246120"/>
+            <a:ext cx="2602153" cy="1371600"/>
           </a:xfrm>
           <a:prstGeom prst="roundRect">
             <a:avLst>
@@ -12922,66 +13964,14 @@
       </p:sp>
       <p:sp>
         <p:nvSpPr>
-          <p:cNvPr id="13" name="Oval 12"/>
-          <p:cNvSpPr/>
-          <p:nvPr/>
-        </p:nvSpPr>
-        <p:spPr>
-          <a:xfrm>
-            <a:off x="8402116" y="2194560"/>
-            <a:ext cx="457200" cy="457200"/>
-          </a:xfrm>
-          <a:prstGeom prst="ellipse">
-            <a:avLst/>
-          </a:prstGeom>
-          <a:solidFill>
-            <a:srgbClr val="1F3A5F"/>
-          </a:solidFill>
-          <a:ln>
-            <a:noFill/>
-          </a:ln>
-        </p:spPr>
-        <p:style>
-          <a:lnRef idx="1">
-            <a:schemeClr val="accent1"/>
-          </a:lnRef>
-          <a:fillRef idx="3">
-            <a:schemeClr val="accent1"/>
-          </a:fillRef>
-          <a:effectRef idx="2">
-            <a:schemeClr val="accent1"/>
-          </a:effectRef>
-          <a:fontRef idx="minor">
-            <a:schemeClr val="lt1"/>
-          </a:fontRef>
-        </p:style>
-        <p:txBody>
-          <a:bodyPr rtlCol="0" anchor="ctr" lIns="0" rIns="0" tIns="0" bIns="0"/>
-          <a:lstStyle/>
-          <a:p>
-            <a:pPr algn="ctr"/>
-            <a:r>
-              <a:rPr sz="1600" b="1">
-                <a:solidFill>
-                  <a:srgbClr val="FFFFFF"/>
-                </a:solidFill>
-                <a:latin typeface="Calibri"/>
-              </a:rPr>
-              <a:t>3</a:t>
-            </a:r>
-          </a:p>
-        </p:txBody>
-      </p:sp>
-      <p:sp>
-        <p:nvSpPr>
-          <p:cNvPr id="14" name="TextBox 13"/>
+          <p:cNvPr id="16" name="TextBox 15"/>
           <p:cNvSpPr txBox="1"/>
           <p:nvPr/>
         </p:nvSpPr>
         <p:spPr>
           <a:xfrm>
-            <a:off x="8402116" y="2743200"/>
-            <a:ext cx="2966618" cy="365760"/>
+            <a:off x="6374739" y="3374136"/>
+            <a:ext cx="2272969" cy="1143000"/>
           </a:xfrm>
           <a:prstGeom prst="rect">
             <a:avLst/>
@@ -12993,6 +13983,22 @@
             <a:spAutoFit/>
           </a:bodyPr>
           <a:lstStyle/>
+          <a:p>
+            <a:pPr algn="l">
+              <a:spcAft>
+                <a:spcPts val="300"/>
+              </a:spcAft>
+            </a:pPr>
+            <a:r>
+              <a:rPr sz="1100" b="1" i="0">
+                <a:solidFill>
+                  <a:srgbClr val="5F6B7A"/>
+                </a:solidFill>
+                <a:latin typeface="Calibri"/>
+              </a:rPr>
+              <a:t>Art. 7(1) and 7(4) · HR Operations</a:t>
+            </a:r>
+          </a:p>
           <a:p>
             <a:pPr algn="l">
               <a:spcAft>
@@ -13000,66 +14006,27 @@
               </a:spcAft>
             </a:pPr>
             <a:r>
-              <a:rPr sz="1600" b="1" i="0">
+              <a:rPr sz="1100" b="0" i="0">
                 <a:solidFill>
                   <a:srgbClr val="1B2430"/>
                 </a:solidFill>
                 <a:latin typeface="Calibri"/>
               </a:rPr>
-              <a:t>Review Sales territories</a:t>
-            </a:r>
-          </a:p>
-        </p:txBody>
-      </p:sp>
-      <p:sp>
-        <p:nvSpPr>
-          <p:cNvPr id="15" name="TextBox 14"/>
-          <p:cNvSpPr txBox="1"/>
-          <p:nvPr/>
-        </p:nvSpPr>
-        <p:spPr>
-          <a:xfrm>
-            <a:off x="8402116" y="3127248"/>
-            <a:ext cx="2966618" cy="640080"/>
-          </a:xfrm>
-          <a:prstGeom prst="rect">
-            <a:avLst/>
-          </a:prstGeom>
-          <a:noFill/>
-        </p:spPr>
-        <p:txBody>
-          <a:bodyPr wrap="square" anchor="t" lIns="0" rIns="0" tIns="0" bIns="0">
-            <a:spAutoFit/>
-          </a:bodyPr>
-          <a:lstStyle/>
-          <a:p>
-            <a:pPr algn="l">
-              <a:spcAft>
-                <a:spcPts val="600"/>
-              </a:spcAft>
-            </a:pPr>
-            <a:r>
-              <a:rPr sz="1300" b="0" i="0">
-                <a:solidFill>
-                  <a:srgbClr val="5F6B7A"/>
-                </a:solidFill>
-                <a:latin typeface="Calibri"/>
-              </a:rPr>
-              <a:t>And every other rule that decides who can earn a component.</a:t>
-            </a:r>
-          </a:p>
-        </p:txBody>
-      </p:sp>
-      <p:sp>
-        <p:nvSpPr>
-          <p:cNvPr id="16" name="Rounded Rectangle 15"/>
+              <a:t>Workers can request their own pay level and the average pay by sex for their category, answered in writing within two months</a:t>
+            </a:r>
+          </a:p>
+        </p:txBody>
+      </p:sp>
+      <p:sp>
+        <p:nvSpPr>
+          <p:cNvPr id="17" name="Rounded Rectangle 16"/>
           <p:cNvSpPr/>
           <p:nvPr/>
         </p:nvSpPr>
         <p:spPr>
           <a:xfrm>
-            <a:off x="548640" y="4069080"/>
-            <a:ext cx="3515258" cy="1874519"/>
+            <a:off x="9040901" y="3246120"/>
+            <a:ext cx="2602153" cy="1371600"/>
           </a:xfrm>
           <a:prstGeom prst="roundRect">
             <a:avLst>
@@ -13098,66 +14065,14 @@
       </p:sp>
       <p:sp>
         <p:nvSpPr>
-          <p:cNvPr id="17" name="Oval 16"/>
-          <p:cNvSpPr/>
-          <p:nvPr/>
-        </p:nvSpPr>
-        <p:spPr>
-          <a:xfrm>
-            <a:off x="822960" y="4343400"/>
-            <a:ext cx="457200" cy="457200"/>
-          </a:xfrm>
-          <a:prstGeom prst="ellipse">
-            <a:avLst/>
-          </a:prstGeom>
-          <a:solidFill>
-            <a:srgbClr val="1F3A5F"/>
-          </a:solidFill>
-          <a:ln>
-            <a:noFill/>
-          </a:ln>
-        </p:spPr>
-        <p:style>
-          <a:lnRef idx="1">
-            <a:schemeClr val="accent1"/>
-          </a:lnRef>
-          <a:fillRef idx="3">
-            <a:schemeClr val="accent1"/>
-          </a:fillRef>
-          <a:effectRef idx="2">
-            <a:schemeClr val="accent1"/>
-          </a:effectRef>
-          <a:fontRef idx="minor">
-            <a:schemeClr val="lt1"/>
-          </a:fontRef>
-        </p:style>
-        <p:txBody>
-          <a:bodyPr rtlCol="0" anchor="ctr" lIns="0" rIns="0" tIns="0" bIns="0"/>
-          <a:lstStyle/>
-          <a:p>
-            <a:pPr algn="ctr"/>
-            <a:r>
-              <a:rPr sz="1600" b="1">
-                <a:solidFill>
-                  <a:srgbClr val="FFFFFF"/>
-                </a:solidFill>
-                <a:latin typeface="Calibri"/>
-              </a:rPr>
-              <a:t>4</a:t>
-            </a:r>
-          </a:p>
-        </p:txBody>
-      </p:sp>
-      <p:sp>
-        <p:nvSpPr>
           <p:cNvPr id="18" name="TextBox 17"/>
           <p:cNvSpPr txBox="1"/>
           <p:nvPr/>
         </p:nvSpPr>
         <p:spPr>
           <a:xfrm>
-            <a:off x="822960" y="4892040"/>
-            <a:ext cx="2966618" cy="365760"/>
+            <a:off x="9205493" y="3374136"/>
+            <a:ext cx="2272969" cy="1143000"/>
           </a:xfrm>
           <a:prstGeom prst="rect">
             <a:avLst/>
@@ -13169,6 +14084,22 @@
             <a:spAutoFit/>
           </a:bodyPr>
           <a:lstStyle/>
+          <a:p>
+            <a:pPr algn="l">
+              <a:spcAft>
+                <a:spcPts val="300"/>
+              </a:spcAft>
+            </a:pPr>
+            <a:r>
+              <a:rPr sz="1100" b="1" i="0">
+                <a:solidFill>
+                  <a:srgbClr val="5F6B7A"/>
+                </a:solidFill>
+                <a:latin typeface="Calibri"/>
+              </a:rPr>
+              <a:t>Art. 7(3) · HR Operations</a:t>
+            </a:r>
+          </a:p>
           <a:p>
             <a:pPr algn="l">
               <a:spcAft>
@@ -13176,66 +14107,27 @@
               </a:spcAft>
             </a:pPr>
             <a:r>
-              <a:rPr sz="1600" b="1" i="0">
+              <a:rPr sz="1100" b="0" i="0">
                 <a:solidFill>
                   <a:srgbClr val="1B2430"/>
                 </a:solidFill>
                 <a:latin typeface="Calibri"/>
               </a:rPr>
-              <a:t>Fix recruitment now</a:t>
-            </a:r>
-          </a:p>
-        </p:txBody>
-      </p:sp>
-      <p:sp>
-        <p:nvSpPr>
-          <p:cNvPr id="19" name="TextBox 18"/>
-          <p:cNvSpPr txBox="1"/>
-          <p:nvPr/>
-        </p:nvSpPr>
-        <p:spPr>
-          <a:xfrm>
-            <a:off x="822960" y="5276088"/>
-            <a:ext cx="2966618" cy="640080"/>
-          </a:xfrm>
-          <a:prstGeom prst="rect">
-            <a:avLst/>
-          </a:prstGeom>
-          <a:noFill/>
-        </p:spPr>
-        <p:txBody>
-          <a:bodyPr wrap="square" anchor="t" lIns="0" rIns="0" tIns="0" bIns="0">
-            <a:spAutoFit/>
-          </a:bodyPr>
-          <a:lstStyle/>
-          <a:p>
-            <a:pPr algn="l">
-              <a:spcAft>
-                <a:spcPts val="600"/>
-              </a:spcAft>
-            </a:pPr>
-            <a:r>
-              <a:rPr sz="1300" b="0" i="0">
-                <a:solidFill>
-                  <a:srgbClr val="5F6B7A"/>
-                </a:solidFill>
-                <a:latin typeface="Calibri"/>
-              </a:rPr>
-              <a:t>Pay ranges in vacancies, no pay-history questions, neutral titles.</a:t>
-            </a:r>
-          </a:p>
-        </p:txBody>
-      </p:sp>
-      <p:sp>
-        <p:nvSpPr>
-          <p:cNvPr id="20" name="Rounded Rectangle 19"/>
+              <a:t>Workers are told every year of their right to request that information</a:t>
+            </a:r>
+          </a:p>
+        </p:txBody>
+      </p:sp>
+      <p:sp>
+        <p:nvSpPr>
+          <p:cNvPr id="19" name="Rounded Rectangle 18"/>
           <p:cNvSpPr/>
           <p:nvPr/>
         </p:nvSpPr>
         <p:spPr>
           <a:xfrm>
-            <a:off x="4338218" y="4069080"/>
-            <a:ext cx="3515258" cy="1874519"/>
+            <a:off x="548640" y="4800600"/>
+            <a:ext cx="2602153" cy="1371600"/>
           </a:xfrm>
           <a:prstGeom prst="roundRect">
             <a:avLst>
@@ -13274,66 +14166,14 @@
       </p:sp>
       <p:sp>
         <p:nvSpPr>
-          <p:cNvPr id="21" name="Oval 20"/>
-          <p:cNvSpPr/>
-          <p:nvPr/>
-        </p:nvSpPr>
-        <p:spPr>
-          <a:xfrm>
-            <a:off x="4612538" y="4343400"/>
-            <a:ext cx="457200" cy="457200"/>
-          </a:xfrm>
-          <a:prstGeom prst="ellipse">
-            <a:avLst/>
-          </a:prstGeom>
-          <a:solidFill>
-            <a:srgbClr val="1F3A5F"/>
-          </a:solidFill>
-          <a:ln>
-            <a:noFill/>
-          </a:ln>
-        </p:spPr>
-        <p:style>
-          <a:lnRef idx="1">
-            <a:schemeClr val="accent1"/>
-          </a:lnRef>
-          <a:fillRef idx="3">
-            <a:schemeClr val="accent1"/>
-          </a:fillRef>
-          <a:effectRef idx="2">
-            <a:schemeClr val="accent1"/>
-          </a:effectRef>
-          <a:fontRef idx="minor">
-            <a:schemeClr val="lt1"/>
-          </a:fontRef>
-        </p:style>
-        <p:txBody>
-          <a:bodyPr rtlCol="0" anchor="ctr" lIns="0" rIns="0" tIns="0" bIns="0"/>
-          <a:lstStyle/>
-          <a:p>
-            <a:pPr algn="ctr"/>
-            <a:r>
-              <a:rPr sz="1600" b="1">
-                <a:solidFill>
-                  <a:srgbClr val="FFFFFF"/>
-                </a:solidFill>
-                <a:latin typeface="Calibri"/>
-              </a:rPr>
-              <a:t>5</a:t>
-            </a:r>
-          </a:p>
-        </p:txBody>
-      </p:sp>
-      <p:sp>
-        <p:nvSpPr>
-          <p:cNvPr id="22" name="TextBox 21"/>
+          <p:cNvPr id="20" name="TextBox 19"/>
           <p:cNvSpPr txBox="1"/>
           <p:nvPr/>
         </p:nvSpPr>
         <p:spPr>
           <a:xfrm>
-            <a:off x="4612538" y="4892040"/>
-            <a:ext cx="2966618" cy="365760"/>
+            <a:off x="713232" y="4928616"/>
+            <a:ext cx="2272969" cy="1143000"/>
           </a:xfrm>
           <a:prstGeom prst="rect">
             <a:avLst/>
@@ -13345,6 +14185,22 @@
             <a:spAutoFit/>
           </a:bodyPr>
           <a:lstStyle/>
+          <a:p>
+            <a:pPr algn="l">
+              <a:spcAft>
+                <a:spcPts val="300"/>
+              </a:spcAft>
+            </a:pPr>
+            <a:r>
+              <a:rPr sz="1100" b="1" i="0">
+                <a:solidFill>
+                  <a:srgbClr val="5F6B7A"/>
+                </a:solidFill>
+                <a:latin typeface="Calibri"/>
+              </a:rPr>
+              <a:t>Art. 8 · HR Operations</a:t>
+            </a:r>
+          </a:p>
           <a:p>
             <a:pPr algn="l">
               <a:spcAft>
@@ -13352,66 +14208,27 @@
               </a:spcAft>
             </a:pPr>
             <a:r>
-              <a:rPr sz="1600" b="1" i="0">
+              <a:rPr sz="1100" b="0" i="0">
                 <a:solidFill>
                   <a:srgbClr val="1B2430"/>
                 </a:solidFill>
                 <a:latin typeface="Calibri"/>
               </a:rPr>
-              <a:t>Open information route</a:t>
-            </a:r>
-          </a:p>
-        </p:txBody>
-      </p:sp>
-      <p:sp>
-        <p:nvSpPr>
-          <p:cNvPr id="23" name="TextBox 22"/>
-          <p:cNvSpPr txBox="1"/>
-          <p:nvPr/>
-        </p:nvSpPr>
-        <p:spPr>
-          <a:xfrm>
-            <a:off x="4612538" y="5276088"/>
-            <a:ext cx="2966618" cy="640080"/>
-          </a:xfrm>
-          <a:prstGeom prst="rect">
-            <a:avLst/>
-          </a:prstGeom>
-          <a:noFill/>
-        </p:spPr>
-        <p:txBody>
-          <a:bodyPr wrap="square" anchor="t" lIns="0" rIns="0" tIns="0" bIns="0">
-            <a:spAutoFit/>
-          </a:bodyPr>
-          <a:lstStyle/>
-          <a:p>
-            <a:pPr algn="l">
-              <a:spcAft>
-                <a:spcPts val="600"/>
-              </a:spcAft>
-            </a:pPr>
-            <a:r>
-              <a:rPr sz="1300" b="0" i="0">
-                <a:solidFill>
-                  <a:srgbClr val="5F6B7A"/>
-                </a:solidFill>
-                <a:latin typeface="Calibri"/>
-              </a:rPr>
-              <a:t>Written answers within two months; an annual notice to workers.</a:t>
-            </a:r>
-          </a:p>
-        </p:txBody>
-      </p:sp>
-      <p:sp>
-        <p:nvSpPr>
-          <p:cNvPr id="24" name="Rounded Rectangle 23"/>
+              <a:t>Information for workers and applicants is accessible to persons with disabilities</a:t>
+            </a:r>
+          </a:p>
+        </p:txBody>
+      </p:sp>
+      <p:sp>
+        <p:nvSpPr>
+          <p:cNvPr id="21" name="Rounded Rectangle 20"/>
           <p:cNvSpPr/>
           <p:nvPr/>
         </p:nvSpPr>
         <p:spPr>
           <a:xfrm>
-            <a:off x="8127796" y="4069080"/>
-            <a:ext cx="3515258" cy="1874519"/>
+            <a:off x="3379393" y="4800600"/>
+            <a:ext cx="2602153" cy="1371600"/>
           </a:xfrm>
           <a:prstGeom prst="roundRect">
             <a:avLst>
@@ -13450,24 +14267,82 @@
       </p:sp>
       <p:sp>
         <p:nvSpPr>
-          <p:cNvPr id="25" name="Oval 24"/>
+          <p:cNvPr id="22" name="TextBox 21"/>
+          <p:cNvSpPr txBox="1"/>
+          <p:nvPr/>
+        </p:nvSpPr>
+        <p:spPr>
+          <a:xfrm>
+            <a:off x="3543985" y="4928616"/>
+            <a:ext cx="2272969" cy="1143000"/>
+          </a:xfrm>
+          <a:prstGeom prst="rect">
+            <a:avLst/>
+          </a:prstGeom>
+          <a:noFill/>
+        </p:spPr>
+        <p:txBody>
+          <a:bodyPr wrap="square" anchor="t" lIns="0" rIns="0" tIns="0" bIns="0">
+            <a:spAutoFit/>
+          </a:bodyPr>
+          <a:lstStyle/>
+          <a:p>
+            <a:pPr algn="l">
+              <a:spcAft>
+                <a:spcPts val="300"/>
+              </a:spcAft>
+            </a:pPr>
+            <a:r>
+              <a:rPr sz="1100" b="1" i="0">
+                <a:solidFill>
+                  <a:srgbClr val="5F6B7A"/>
+                </a:solidFill>
+                <a:latin typeface="Calibri"/>
+              </a:rPr>
+              <a:t>Art. 9(6) · HR Director</a:t>
+            </a:r>
+          </a:p>
+          <a:p>
+            <a:pPr algn="l">
+              <a:spcAft>
+                <a:spcPts val="600"/>
+              </a:spcAft>
+            </a:pPr>
+            <a:r>
+              <a:rPr sz="1100" b="0" i="0">
+                <a:solidFill>
+                  <a:srgbClr val="1B2430"/>
+                </a:solidFill>
+                <a:latin typeface="Calibri"/>
+              </a:rPr>
+              <a:t>Management confirms the accuracy of the report after consulting workers' representatives, who can see the method</a:t>
+            </a:r>
+          </a:p>
+        </p:txBody>
+      </p:sp>
+      <p:sp>
+        <p:nvSpPr>
+          <p:cNvPr id="23" name="Rounded Rectangle 22"/>
           <p:cNvSpPr/>
           <p:nvPr/>
         </p:nvSpPr>
         <p:spPr>
           <a:xfrm>
-            <a:off x="8402116" y="4343400"/>
-            <a:ext cx="457200" cy="457200"/>
-          </a:xfrm>
-          <a:prstGeom prst="ellipse">
-            <a:avLst/>
+            <a:off x="6210147" y="4800600"/>
+            <a:ext cx="2602153" cy="1371600"/>
+          </a:xfrm>
+          <a:prstGeom prst="roundRect">
+            <a:avLst>
+              <a:gd name="adj" fmla="val 8000"/>
+            </a:avLst>
           </a:prstGeom>
           <a:solidFill>
-            <a:srgbClr val="1F3A5F"/>
+            <a:srgbClr val="F1F4F8"/>
           </a:solidFill>
           <a:ln>
             <a:noFill/>
           </a:ln>
+          <a:effectLst/>
         </p:spPr>
         <p:style>
           <a:lnRef idx="1">
@@ -13484,32 +14359,23 @@
           </a:fontRef>
         </p:style>
         <p:txBody>
-          <a:bodyPr rtlCol="0" anchor="ctr" lIns="0" rIns="0" tIns="0" bIns="0"/>
+          <a:bodyPr rtlCol="0" anchor="ctr"/>
           <a:lstStyle/>
           <a:p>
             <a:pPr algn="ctr"/>
-            <a:r>
-              <a:rPr sz="1600" b="1">
-                <a:solidFill>
-                  <a:srgbClr val="FFFFFF"/>
-                </a:solidFill>
-                <a:latin typeface="Calibri"/>
-              </a:rPr>
-              <a:t>6</a:t>
-            </a:r>
-          </a:p>
-        </p:txBody>
-      </p:sp>
-      <p:sp>
-        <p:nvSpPr>
-          <p:cNvPr id="26" name="TextBox 25"/>
+          </a:p>
+        </p:txBody>
+      </p:sp>
+      <p:sp>
+        <p:nvSpPr>
+          <p:cNvPr id="24" name="TextBox 23"/>
           <p:cNvSpPr txBox="1"/>
           <p:nvPr/>
         </p:nvSpPr>
         <p:spPr>
           <a:xfrm>
-            <a:off x="8402116" y="4892040"/>
-            <a:ext cx="2966618" cy="365760"/>
+            <a:off x="6374739" y="4928616"/>
+            <a:ext cx="2272969" cy="1143000"/>
           </a:xfrm>
           <a:prstGeom prst="rect">
             <a:avLst/>
@@ -13521,6 +14387,22 @@
             <a:spAutoFit/>
           </a:bodyPr>
           <a:lstStyle/>
+          <a:p>
+            <a:pPr algn="l">
+              <a:spcAft>
+                <a:spcPts val="300"/>
+              </a:spcAft>
+            </a:pPr>
+            <a:r>
+              <a:rPr sz="1100" b="1" i="0">
+                <a:solidFill>
+                  <a:srgbClr val="5F6B7A"/>
+                </a:solidFill>
+                <a:latin typeface="Calibri"/>
+              </a:rPr>
+              <a:t>Art. 9(9) · HR Operations</a:t>
+            </a:r>
+          </a:p>
           <a:p>
             <a:pPr algn="l">
               <a:spcAft>
@@ -13528,27 +14410,27 @@
               </a:spcAft>
             </a:pPr>
             <a:r>
-              <a:rPr sz="1600" b="1" i="0">
+              <a:rPr sz="1100" b="0" i="0">
                 <a:solidFill>
                   <a:srgbClr val="1B2430"/>
                 </a:solidFill>
                 <a:latin typeface="Calibri"/>
               </a:rPr>
-              <a:t>Rerun on 2026 payroll</a:t>
-            </a:r>
-          </a:p>
-        </p:txBody>
-      </p:sp>
-      <p:sp>
-        <p:nvSpPr>
-          <p:cNvPr id="27" name="TextBox 26"/>
+              <a:t>Pay gaps by category of workers are provided to all workers and their representatives</a:t>
+            </a:r>
+          </a:p>
+        </p:txBody>
+      </p:sp>
+      <p:sp>
+        <p:nvSpPr>
+          <p:cNvPr id="25" name="TextBox 24"/>
           <p:cNvSpPr txBox="1"/>
           <p:nvPr/>
         </p:nvSpPr>
         <p:spPr>
           <a:xfrm>
-            <a:off x="8402116" y="5276088"/>
-            <a:ext cx="2966618" cy="640080"/>
+            <a:off x="548640" y="6446520"/>
+            <a:ext cx="8229600" cy="274320"/>
           </a:xfrm>
           <a:prstGeom prst="rect">
             <a:avLst/>
@@ -13567,51 +14449,12 @@
               </a:spcAft>
             </a:pPr>
             <a:r>
-              <a:rPr sz="1300" b="0" i="0">
+              <a:rPr sz="1000" b="0" i="0">
                 <a:solidFill>
                   <a:srgbClr val="5F6B7A"/>
                 </a:solidFill>
                 <a:latin typeface="Calibri"/>
               </a:rPr>
-              <a:t>Once national rules are final; management sign-off after consultation.</a:t>
-            </a:r>
-          </a:p>
-        </p:txBody>
-      </p:sp>
-      <p:sp>
-        <p:nvSpPr>
-          <p:cNvPr id="28" name="TextBox 27"/>
-          <p:cNvSpPr txBox="1"/>
-          <p:nvPr/>
-        </p:nvSpPr>
-        <p:spPr>
-          <a:xfrm>
-            <a:off x="548640" y="6446520"/>
-            <a:ext cx="8229600" cy="274320"/>
-          </a:xfrm>
-          <a:prstGeom prst="rect">
-            <a:avLst/>
-          </a:prstGeom>
-          <a:noFill/>
-        </p:spPr>
-        <p:txBody>
-          <a:bodyPr wrap="square" anchor="t" lIns="0" rIns="0" tIns="0" bIns="0">
-            <a:spAutoFit/>
-          </a:bodyPr>
-          <a:lstStyle/>
-          <a:p>
-            <a:pPr algn="l">
-              <a:spcAft>
-                <a:spcPts val="600"/>
-              </a:spcAft>
-            </a:pPr>
-            <a:r>
-              <a:rPr sz="1000" b="0" i="0">
-                <a:solidFill>
-                  <a:srgbClr val="5F6B7A"/>
-                </a:solidFill>
-                <a:latin typeface="Calibri"/>
-              </a:rPr>
               <a:t>Pay transparency readiness · dry run on synthetic data · not legal advice</a:t>
             </a:r>
           </a:p>
@@ -13619,7 +14462,7 @@
       </p:sp>
       <p:sp>
         <p:nvSpPr>
-          <p:cNvPr id="29" name="TextBox 28"/>
+          <p:cNvPr id="26" name="TextBox 25"/>
           <p:cNvSpPr txBox="1"/>
           <p:nvPr/>
         </p:nvSpPr>

</xml_diff>